<commit_message>
Correct swap: restore mid-market, remove evidence slide, keep team roster
Rebuilt on the user's edited 21pp version:
- Restore 'Why mid-market is the sweet spot' (page 6)
- Remove 'The evidence: constructive engagement works'
- Keep team roster 'The people behind the track record' after the team page
- Renumber footers 1-21

https://claude.ai/code/session_01HRMxSvt6t94q3GFGUqavQe
</commit_message>
<xml_diff>
--- a/Athanase_Endowment_Pitch_21pp.pptx
+++ b/Athanase_Endowment_Pitch_21pp.pptx
@@ -13,7 +13,7 @@
     <p:sldId id="263" r:id="rId7"/>
     <p:sldId id="267" r:id="rId8"/>
     <p:sldId id="284" r:id="rId9"/>
-    <p:sldId id="274" r:id="rId11"/>
+    <p:sldId id="271" r:id="rId10"/>
     <p:sldId id="278" r:id="rId12"/>
     <p:sldId id="339" r:id="rId13"/>
     <p:sldId id="279" r:id="rId14"/>
@@ -26483,7 +26483,7 @@
 </p:sld>
 </file>
 
-<file path=ppt/slides/slide7.xml><?xml version="1.0" encoding="utf-8"?>
+<file path=ppt/slides/slide6.xml><?xml version="1.0" encoding="utf-8"?>
 <p:sld xmlns:a="http://schemas.openxmlformats.org/drawingml/2006/main" xmlns:r="http://schemas.openxmlformats.org/officeDocument/2006/relationships" xmlns:p="http://schemas.openxmlformats.org/presentationml/2006/main">
   <p:cSld>
     <p:spTree>
@@ -26648,7 +26648,7 @@
                 </a:solidFill>
                 <a:latin typeface="Arial"/>
               </a:rPr>
-              <a:t>Table 3</a:t>
+              <a:t>Table 2</a:t>
             </a:r>
           </a:p>
         </p:txBody>
@@ -26735,7 +26735,7 @@
                 </a:solidFill>
                 <a:latin typeface="Times New Roman"/>
               </a:rPr>
-              <a:t>The evidence: constructive engagement works</a:t>
+              <a:t>Why mid-market is the sweet spot</a:t>
             </a:r>
           </a:p>
         </p:txBody>
@@ -26777,7 +26777,7 @@
                 </a:solidFill>
                 <a:latin typeface="Arial"/>
               </a:rPr>
-              <a:t>Three decades of peer-reviewed research — across the US and Europe — converge on the same finding.</a:t>
+              <a:t>Big enough to run well, small enough to change — and to grow. The engaged-ownership opportunity is richest in the middle.</a:t>
             </a:r>
           </a:p>
         </p:txBody>
@@ -26832,8 +26832,87 @@
         </p:nvSpPr>
         <p:spPr>
           <a:xfrm>
-            <a:off x="438922" y="2292096"/>
-            <a:ext cx="2450653" cy="390144"/>
+            <a:off x="402346" y="2292096"/>
+            <a:ext cx="1828845" cy="390144"/>
+          </a:xfrm>
+          <a:prstGeom prst="rect">
+            <a:avLst/>
+          </a:prstGeom>
+          <a:solidFill>
+            <a:srgbClr val="FFFFFF"/>
+          </a:solidFill>
+          <a:ln>
+            <a:noFill/>
+          </a:ln>
+          <a:effectLst/>
+        </p:spPr>
+        <p:style>
+          <a:lnRef idx="1">
+            <a:schemeClr val="accent1"/>
+          </a:lnRef>
+          <a:fillRef idx="3">
+            <a:schemeClr val="accent1"/>
+          </a:fillRef>
+          <a:effectRef idx="2">
+            <a:schemeClr val="accent1"/>
+          </a:effectRef>
+          <a:fontRef idx="minor">
+            <a:schemeClr val="lt1"/>
+          </a:fontRef>
+        </p:style>
+        <p:txBody>
+          <a:bodyPr rtlCol="0" anchor="ctr"/>
+          <a:lstStyle/>
+          <a:p>
+            <a:pPr algn="ctr"/>
+            <a:endParaRPr/>
+          </a:p>
+        </p:txBody>
+      </p:sp>
+      <p:sp>
+        <p:nvSpPr>
+          <p:cNvPr id="11" name="TextBox 10"/>
+          <p:cNvSpPr txBox="1"/>
+          <p:nvPr/>
+        </p:nvSpPr>
+        <p:spPr>
+          <a:xfrm>
+            <a:off x="490130" y="2292096"/>
+            <a:ext cx="1682538" cy="390144"/>
+          </a:xfrm>
+          <a:prstGeom prst="rect">
+            <a:avLst/>
+          </a:prstGeom>
+          <a:noFill/>
+        </p:spPr>
+        <p:txBody>
+          <a:bodyPr wrap="square" lIns="0" tIns="0" rIns="0" bIns="0" anchor="ctr">
+            <a:spAutoFit/>
+          </a:bodyPr>
+          <a:lstStyle/>
+          <a:p>
+            <a:pPr algn="l">
+              <a:lnSpc>
+                <a:spcPct val="105000"/>
+              </a:lnSpc>
+              <a:spcAft>
+                <a:spcPts val="0"/>
+              </a:spcAft>
+            </a:pPr>
+            <a:endParaRPr/>
+          </a:p>
+        </p:txBody>
+      </p:sp>
+      <p:sp>
+        <p:nvSpPr>
+          <p:cNvPr id="12" name="Rectangle 11"/>
+          <p:cNvSpPr/>
+          <p:nvPr/>
+        </p:nvSpPr>
+        <p:spPr>
+          <a:xfrm>
+            <a:off x="2231191" y="2292096"/>
+            <a:ext cx="2377499" cy="390144"/>
           </a:xfrm>
           <a:prstGeom prst="rect">
             <a:avLst/>
@@ -26871,14 +26950,14 @@
       </p:sp>
       <p:sp>
         <p:nvSpPr>
-          <p:cNvPr id="11" name="TextBox 10"/>
-          <p:cNvSpPr txBox="1"/>
-          <p:nvPr/>
-        </p:nvSpPr>
-        <p:spPr>
-          <a:xfrm>
-            <a:off x="534022" y="2292096"/>
-            <a:ext cx="2275084" cy="390144"/>
+          <p:cNvPr id="13" name="TextBox 12"/>
+          <p:cNvSpPr txBox="1"/>
+          <p:nvPr/>
+        </p:nvSpPr>
+        <p:spPr>
+          <a:xfrm>
+            <a:off x="2318976" y="2292096"/>
+            <a:ext cx="2231191" cy="390144"/>
           </a:xfrm>
           <a:prstGeom prst="rect">
             <a:avLst/>
@@ -26893,34 +26972,121 @@
           <a:p>
             <a:pPr algn="l">
               <a:lnSpc>
-                <a:spcPct val="108000"/>
+                <a:spcPct val="105000"/>
               </a:lnSpc>
               <a:spcAft>
                 <a:spcPts val="0"/>
               </a:spcAft>
             </a:pPr>
             <a:r>
-              <a:rPr sz="880" b="1" i="0">
+              <a:rPr sz="960" b="1" i="0">
                 <a:solidFill>
                   <a:srgbClr val="FFFFFF"/>
                 </a:solidFill>
                 <a:latin typeface="Arial"/>
               </a:rPr>
-              <a:t>Study</a:t>
-            </a:r>
-          </a:p>
-        </p:txBody>
-      </p:sp>
-      <p:sp>
-        <p:nvSpPr>
-          <p:cNvPr id="12" name="Rectangle 11"/>
+              <a:t>Small-cap</a:t>
+            </a:r>
+          </a:p>
+        </p:txBody>
+      </p:sp>
+      <p:sp>
+        <p:nvSpPr>
+          <p:cNvPr id="14" name="Rectangle 13"/>
           <p:cNvSpPr/>
           <p:nvPr/>
         </p:nvSpPr>
         <p:spPr>
           <a:xfrm>
-            <a:off x="2889576" y="2292096"/>
-            <a:ext cx="1865422" cy="390144"/>
+            <a:off x="4608691" y="2292096"/>
+            <a:ext cx="2560384" cy="390144"/>
+          </a:xfrm>
+          <a:prstGeom prst="rect">
+            <a:avLst/>
+          </a:prstGeom>
+          <a:solidFill>
+            <a:srgbClr val="152130"/>
+          </a:solidFill>
+          <a:ln>
+            <a:noFill/>
+          </a:ln>
+          <a:effectLst/>
+        </p:spPr>
+        <p:style>
+          <a:lnRef idx="1">
+            <a:schemeClr val="accent1"/>
+          </a:lnRef>
+          <a:fillRef idx="3">
+            <a:schemeClr val="accent1"/>
+          </a:fillRef>
+          <a:effectRef idx="2">
+            <a:schemeClr val="accent1"/>
+          </a:effectRef>
+          <a:fontRef idx="minor">
+            <a:schemeClr val="lt1"/>
+          </a:fontRef>
+        </p:style>
+        <p:txBody>
+          <a:bodyPr rtlCol="0" anchor="ctr"/>
+          <a:lstStyle/>
+          <a:p>
+            <a:pPr algn="ctr"/>
+            <a:endParaRPr/>
+          </a:p>
+        </p:txBody>
+      </p:sp>
+      <p:sp>
+        <p:nvSpPr>
+          <p:cNvPr id="15" name="TextBox 14"/>
+          <p:cNvSpPr txBox="1"/>
+          <p:nvPr/>
+        </p:nvSpPr>
+        <p:spPr>
+          <a:xfrm>
+            <a:off x="4696475" y="2292096"/>
+            <a:ext cx="2414076" cy="390144"/>
+          </a:xfrm>
+          <a:prstGeom prst="rect">
+            <a:avLst/>
+          </a:prstGeom>
+          <a:noFill/>
+        </p:spPr>
+        <p:txBody>
+          <a:bodyPr wrap="square" lIns="0" tIns="0" rIns="0" bIns="0" anchor="ctr">
+            <a:spAutoFit/>
+          </a:bodyPr>
+          <a:lstStyle/>
+          <a:p>
+            <a:pPr algn="l">
+              <a:lnSpc>
+                <a:spcPct val="105000"/>
+              </a:lnSpc>
+              <a:spcAft>
+                <a:spcPts val="0"/>
+              </a:spcAft>
+            </a:pPr>
+            <a:r>
+              <a:rPr sz="960" b="1" i="0">
+                <a:solidFill>
+                  <a:srgbClr val="FFFFFF"/>
+                </a:solidFill>
+                <a:latin typeface="Arial"/>
+              </a:rPr>
+              <a:t>Mid-market</a:t>
+            </a:r>
+          </a:p>
+        </p:txBody>
+      </p:sp>
+      <p:sp>
+        <p:nvSpPr>
+          <p:cNvPr id="16" name="Rectangle 15"/>
+          <p:cNvSpPr/>
+          <p:nvPr/>
+        </p:nvSpPr>
+        <p:spPr>
+          <a:xfrm>
+            <a:off x="7169075" y="2292096"/>
+            <a:ext cx="2121461" cy="390144"/>
           </a:xfrm>
           <a:prstGeom prst="rect">
             <a:avLst/>
@@ -26958,14 +27124,14 @@
       </p:sp>
       <p:sp>
         <p:nvSpPr>
-          <p:cNvPr id="13" name="TextBox 12"/>
-          <p:cNvSpPr txBox="1"/>
-          <p:nvPr/>
-        </p:nvSpPr>
-        <p:spPr>
-          <a:xfrm>
-            <a:off x="2984676" y="2292096"/>
-            <a:ext cx="1689853" cy="390144"/>
+          <p:cNvPr id="17" name="TextBox 16"/>
+          <p:cNvSpPr txBox="1"/>
+          <p:nvPr/>
+        </p:nvSpPr>
+        <p:spPr>
+          <a:xfrm>
+            <a:off x="7256859" y="2292096"/>
+            <a:ext cx="1975153" cy="390144"/>
           </a:xfrm>
           <a:prstGeom prst="rect">
             <a:avLst/>
@@ -26980,40 +27146,40 @@
           <a:p>
             <a:pPr algn="l">
               <a:lnSpc>
-                <a:spcPct val="108000"/>
+                <a:spcPct val="105000"/>
               </a:lnSpc>
               <a:spcAft>
                 <a:spcPts val="0"/>
               </a:spcAft>
             </a:pPr>
             <a:r>
-              <a:rPr sz="880" b="1" i="0">
+              <a:rPr sz="960" b="1" i="0">
                 <a:solidFill>
                   <a:srgbClr val="FFFFFF"/>
                 </a:solidFill>
                 <a:latin typeface="Arial"/>
               </a:rPr>
-              <a:t>What it covers</a:t>
-            </a:r>
-          </a:p>
-        </p:txBody>
-      </p:sp>
-      <p:sp>
-        <p:nvSpPr>
-          <p:cNvPr id="14" name="Rectangle 13"/>
+              <a:t>Large-cap</a:t>
+            </a:r>
+          </a:p>
+        </p:txBody>
+      </p:sp>
+      <p:sp>
+        <p:nvSpPr>
+          <p:cNvPr id="18" name="Rectangle 17"/>
           <p:cNvSpPr/>
           <p:nvPr/>
         </p:nvSpPr>
         <p:spPr>
           <a:xfrm>
-            <a:off x="4754998" y="2292096"/>
-            <a:ext cx="4579429" cy="390144"/>
+            <a:off x="402346" y="2682240"/>
+            <a:ext cx="1828845" cy="760780"/>
           </a:xfrm>
           <a:prstGeom prst="rect">
             <a:avLst/>
           </a:prstGeom>
           <a:solidFill>
-            <a:srgbClr val="314359"/>
+            <a:srgbClr val="FFFFFF"/>
           </a:solidFill>
           <a:ln>
             <a:noFill/>
@@ -27045,14 +27211,14 @@
       </p:sp>
       <p:sp>
         <p:nvSpPr>
-          <p:cNvPr id="15" name="TextBox 14"/>
-          <p:cNvSpPr txBox="1"/>
-          <p:nvPr/>
-        </p:nvSpPr>
-        <p:spPr>
-          <a:xfrm>
-            <a:off x="4850098" y="2292096"/>
-            <a:ext cx="4403860" cy="390144"/>
+          <p:cNvPr id="19" name="TextBox 18"/>
+          <p:cNvSpPr txBox="1"/>
+          <p:nvPr/>
+        </p:nvSpPr>
+        <p:spPr>
+          <a:xfrm>
+            <a:off x="490130" y="2682240"/>
+            <a:ext cx="1682538" cy="760780"/>
           </a:xfrm>
           <a:prstGeom prst="rect">
             <a:avLst/>
@@ -27067,7 +27233,7 @@
           <a:p>
             <a:pPr algn="l">
               <a:lnSpc>
-                <a:spcPct val="108000"/>
+                <a:spcPct val="105000"/>
               </a:lnSpc>
               <a:spcAft>
                 <a:spcPts val="0"/>
@@ -27076,25 +27242,112 @@
             <a:r>
               <a:rPr sz="880" b="1" i="0">
                 <a:solidFill>
-                  <a:srgbClr val="FFFFFF"/>
-                </a:solidFill>
-                <a:latin typeface="Arial"/>
-              </a:rPr>
-              <a:t>What it establishes</a:t>
-            </a:r>
-          </a:p>
-        </p:txBody>
-      </p:sp>
-      <p:sp>
-        <p:nvSpPr>
-          <p:cNvPr id="16" name="Rectangle 15"/>
+                  <a:srgbClr val="314359"/>
+                </a:solidFill>
+                <a:latin typeface="Arial"/>
+              </a:rPr>
+              <a:t>Organisational depth</a:t>
+            </a:r>
+          </a:p>
+        </p:txBody>
+      </p:sp>
+      <p:sp>
+        <p:nvSpPr>
+          <p:cNvPr id="20" name="Rectangle 19"/>
           <p:cNvSpPr/>
           <p:nvPr/>
         </p:nvSpPr>
         <p:spPr>
           <a:xfrm>
-            <a:off x="438922" y="2682240"/>
-            <a:ext cx="2450653" cy="838809"/>
+            <a:off x="2231191" y="2682240"/>
+            <a:ext cx="2377499" cy="760780"/>
+          </a:xfrm>
+          <a:prstGeom prst="rect">
+            <a:avLst/>
+          </a:prstGeom>
+          <a:solidFill>
+            <a:srgbClr val="FFFFFF"/>
+          </a:solidFill>
+          <a:ln>
+            <a:noFill/>
+          </a:ln>
+          <a:effectLst/>
+        </p:spPr>
+        <p:style>
+          <a:lnRef idx="1">
+            <a:schemeClr val="accent1"/>
+          </a:lnRef>
+          <a:fillRef idx="3">
+            <a:schemeClr val="accent1"/>
+          </a:fillRef>
+          <a:effectRef idx="2">
+            <a:schemeClr val="accent1"/>
+          </a:effectRef>
+          <a:fontRef idx="minor">
+            <a:schemeClr val="lt1"/>
+          </a:fontRef>
+        </p:style>
+        <p:txBody>
+          <a:bodyPr rtlCol="0" anchor="ctr"/>
+          <a:lstStyle/>
+          <a:p>
+            <a:pPr algn="ctr"/>
+            <a:endParaRPr/>
+          </a:p>
+        </p:txBody>
+      </p:sp>
+      <p:sp>
+        <p:nvSpPr>
+          <p:cNvPr id="21" name="TextBox 20"/>
+          <p:cNvSpPr txBox="1"/>
+          <p:nvPr/>
+        </p:nvSpPr>
+        <p:spPr>
+          <a:xfrm>
+            <a:off x="2318976" y="2682240"/>
+            <a:ext cx="2231191" cy="760780"/>
+          </a:xfrm>
+          <a:prstGeom prst="rect">
+            <a:avLst/>
+          </a:prstGeom>
+          <a:noFill/>
+        </p:spPr>
+        <p:txBody>
+          <a:bodyPr wrap="square" lIns="0" tIns="0" rIns="0" bIns="0" anchor="ctr">
+            <a:spAutoFit/>
+          </a:bodyPr>
+          <a:lstStyle/>
+          <a:p>
+            <a:pPr algn="l">
+              <a:lnSpc>
+                <a:spcPct val="105000"/>
+              </a:lnSpc>
+              <a:spcAft>
+                <a:spcPts val="0"/>
+              </a:spcAft>
+            </a:pPr>
+            <a:r>
+              <a:rPr sz="880" b="0" i="0">
+                <a:solidFill>
+                  <a:srgbClr val="556A83"/>
+                </a:solidFill>
+                <a:latin typeface="Arial"/>
+              </a:rPr>
+              <a:t>Often too thin to support a capable team</a:t>
+            </a:r>
+          </a:p>
+        </p:txBody>
+      </p:sp>
+      <p:sp>
+        <p:nvSpPr>
+          <p:cNvPr id="22" name="Rectangle 21"/>
+          <p:cNvSpPr/>
+          <p:nvPr/>
+        </p:nvSpPr>
+        <p:spPr>
+          <a:xfrm>
+            <a:off x="4608691" y="2682240"/>
+            <a:ext cx="2560384" cy="760780"/>
           </a:xfrm>
           <a:prstGeom prst="rect">
             <a:avLst/>
@@ -27132,14 +27385,14 @@
       </p:sp>
       <p:sp>
         <p:nvSpPr>
-          <p:cNvPr id="17" name="TextBox 16"/>
-          <p:cNvSpPr txBox="1"/>
-          <p:nvPr/>
-        </p:nvSpPr>
-        <p:spPr>
-          <a:xfrm>
-            <a:off x="534022" y="2682240"/>
-            <a:ext cx="2275084" cy="838809"/>
+          <p:cNvPr id="23" name="TextBox 22"/>
+          <p:cNvSpPr txBox="1"/>
+          <p:nvPr/>
+        </p:nvSpPr>
+        <p:spPr>
+          <a:xfrm>
+            <a:off x="4696475" y="2682240"/>
+            <a:ext cx="2414076" cy="760780"/>
           </a:xfrm>
           <a:prstGeom prst="rect">
             <a:avLst/>
@@ -27154,34 +27407,121 @@
           <a:p>
             <a:pPr algn="l">
               <a:lnSpc>
-                <a:spcPct val="108000"/>
+                <a:spcPct val="105000"/>
               </a:lnSpc>
               <a:spcAft>
                 <a:spcPts val="0"/>
               </a:spcAft>
             </a:pPr>
             <a:r>
-              <a:rPr sz="800" b="1" i="0">
+              <a:rPr sz="880" b="1" i="0">
                 <a:solidFill>
                   <a:srgbClr val="314359"/>
                 </a:solidFill>
                 <a:latin typeface="Arial"/>
               </a:rPr>
-              <a:t>Brav, Jiang, Partnoy &amp; Thomas (2008) · J. Finance</a:t>
-            </a:r>
-          </a:p>
-        </p:txBody>
-      </p:sp>
-      <p:sp>
-        <p:nvSpPr>
-          <p:cNvPr id="18" name="Rectangle 17"/>
+              <a:t>Enough structure for a real management team and processes</a:t>
+            </a:r>
+          </a:p>
+        </p:txBody>
+      </p:sp>
+      <p:sp>
+        <p:nvSpPr>
+          <p:cNvPr id="24" name="Rectangle 23"/>
           <p:cNvSpPr/>
           <p:nvPr/>
         </p:nvSpPr>
         <p:spPr>
           <a:xfrm>
-            <a:off x="2889576" y="2682240"/>
-            <a:ext cx="1865422" cy="838809"/>
+            <a:off x="7169075" y="2682240"/>
+            <a:ext cx="2121461" cy="760780"/>
+          </a:xfrm>
+          <a:prstGeom prst="rect">
+            <a:avLst/>
+          </a:prstGeom>
+          <a:solidFill>
+            <a:srgbClr val="FFFFFF"/>
+          </a:solidFill>
+          <a:ln>
+            <a:noFill/>
+          </a:ln>
+          <a:effectLst/>
+        </p:spPr>
+        <p:style>
+          <a:lnRef idx="1">
+            <a:schemeClr val="accent1"/>
+          </a:lnRef>
+          <a:fillRef idx="3">
+            <a:schemeClr val="accent1"/>
+          </a:fillRef>
+          <a:effectRef idx="2">
+            <a:schemeClr val="accent1"/>
+          </a:effectRef>
+          <a:fontRef idx="minor">
+            <a:schemeClr val="lt1"/>
+          </a:fontRef>
+        </p:style>
+        <p:txBody>
+          <a:bodyPr rtlCol="0" anchor="ctr"/>
+          <a:lstStyle/>
+          <a:p>
+            <a:pPr algn="ctr"/>
+            <a:endParaRPr/>
+          </a:p>
+        </p:txBody>
+      </p:sp>
+      <p:sp>
+        <p:nvSpPr>
+          <p:cNvPr id="25" name="TextBox 24"/>
+          <p:cNvSpPr txBox="1"/>
+          <p:nvPr/>
+        </p:nvSpPr>
+        <p:spPr>
+          <a:xfrm>
+            <a:off x="7256859" y="2682240"/>
+            <a:ext cx="1975153" cy="760780"/>
+          </a:xfrm>
+          <a:prstGeom prst="rect">
+            <a:avLst/>
+          </a:prstGeom>
+          <a:noFill/>
+        </p:spPr>
+        <p:txBody>
+          <a:bodyPr wrap="square" lIns="0" tIns="0" rIns="0" bIns="0" anchor="ctr">
+            <a:spAutoFit/>
+          </a:bodyPr>
+          <a:lstStyle/>
+          <a:p>
+            <a:pPr algn="l">
+              <a:lnSpc>
+                <a:spcPct val="105000"/>
+              </a:lnSpc>
+              <a:spcAft>
+                <a:spcPts val="0"/>
+              </a:spcAft>
+            </a:pPr>
+            <a:r>
+              <a:rPr sz="880" b="0" i="0">
+                <a:solidFill>
+                  <a:srgbClr val="556A83"/>
+                </a:solidFill>
+                <a:latin typeface="Arial"/>
+              </a:rPr>
+              <a:t>Deep, but layered and slow</a:t>
+            </a:r>
+          </a:p>
+        </p:txBody>
+      </p:sp>
+      <p:sp>
+        <p:nvSpPr>
+          <p:cNvPr id="26" name="Rectangle 25"/>
+          <p:cNvSpPr/>
+          <p:nvPr/>
+        </p:nvSpPr>
+        <p:spPr>
+          <a:xfrm>
+            <a:off x="402346" y="3443020"/>
+            <a:ext cx="1828845" cy="760780"/>
           </a:xfrm>
           <a:prstGeom prst="rect">
             <a:avLst/>
@@ -27219,14 +27559,14 @@
       </p:sp>
       <p:sp>
         <p:nvSpPr>
-          <p:cNvPr id="19" name="TextBox 18"/>
-          <p:cNvSpPr txBox="1"/>
-          <p:nvPr/>
-        </p:nvSpPr>
-        <p:spPr>
-          <a:xfrm>
-            <a:off x="2984676" y="2682240"/>
-            <a:ext cx="1689853" cy="838809"/>
+          <p:cNvPr id="27" name="TextBox 26"/>
+          <p:cNvSpPr txBox="1"/>
+          <p:nvPr/>
+        </p:nvSpPr>
+        <p:spPr>
+          <a:xfrm>
+            <a:off x="490130" y="3443020"/>
+            <a:ext cx="1682538" cy="760780"/>
           </a:xfrm>
           <a:prstGeom prst="rect">
             <a:avLst/>
@@ -27241,34 +27581,34 @@
           <a:p>
             <a:pPr algn="l">
               <a:lnSpc>
-                <a:spcPct val="108000"/>
+                <a:spcPct val="105000"/>
               </a:lnSpc>
               <a:spcAft>
                 <a:spcPts val="0"/>
               </a:spcAft>
             </a:pPr>
             <a:r>
-              <a:rPr sz="760" b="0" i="0">
-                <a:solidFill>
-                  <a:srgbClr val="0E1620"/>
-                </a:solidFill>
-                <a:latin typeface="Arial"/>
-              </a:rPr>
-              <a:t>1,000+ US engagements, 2001–06</a:t>
-            </a:r>
-          </a:p>
-        </p:txBody>
-      </p:sp>
-      <p:sp>
-        <p:nvSpPr>
-          <p:cNvPr id="20" name="Rectangle 19"/>
+              <a:rPr sz="880" b="1" i="0">
+                <a:solidFill>
+                  <a:srgbClr val="314359"/>
+                </a:solidFill>
+                <a:latin typeface="Arial"/>
+              </a:rPr>
+              <a:t>Growth runway</a:t>
+            </a:r>
+          </a:p>
+        </p:txBody>
+      </p:sp>
+      <p:sp>
+        <p:nvSpPr>
+          <p:cNvPr id="28" name="Rectangle 27"/>
           <p:cNvSpPr/>
           <p:nvPr/>
         </p:nvSpPr>
         <p:spPr>
           <a:xfrm>
-            <a:off x="4754998" y="2682240"/>
-            <a:ext cx="4579429" cy="838809"/>
+            <a:off x="2231191" y="3443020"/>
+            <a:ext cx="2377499" cy="760780"/>
           </a:xfrm>
           <a:prstGeom prst="rect">
             <a:avLst/>
@@ -27306,14 +27646,14 @@
       </p:sp>
       <p:sp>
         <p:nvSpPr>
-          <p:cNvPr id="21" name="TextBox 20"/>
-          <p:cNvSpPr txBox="1"/>
-          <p:nvPr/>
-        </p:nvSpPr>
-        <p:spPr>
-          <a:xfrm>
-            <a:off x="4850098" y="2682240"/>
-            <a:ext cx="4403860" cy="838809"/>
+          <p:cNvPr id="29" name="TextBox 28"/>
+          <p:cNvSpPr txBox="1"/>
+          <p:nvPr/>
+        </p:nvSpPr>
+        <p:spPr>
+          <a:xfrm>
+            <a:off x="2318976" y="3443020"/>
+            <a:ext cx="2231191" cy="760780"/>
           </a:xfrm>
           <a:prstGeom prst="rect">
             <a:avLst/>
@@ -27328,34 +27668,208 @@
           <a:p>
             <a:pPr algn="l">
               <a:lnSpc>
-                <a:spcPct val="108000"/>
+                <a:spcPct val="105000"/>
               </a:lnSpc>
               <a:spcAft>
                 <a:spcPts val="0"/>
               </a:spcAft>
             </a:pPr>
             <a:r>
-              <a:rPr sz="760" b="0" i="0">
-                <a:solidFill>
-                  <a:srgbClr val="0E1620"/>
-                </a:solidFill>
-                <a:latin typeface="Arial"/>
-              </a:rPr>
-              <a:t>Activists “seldom seek control” and are “nonconfrontational”; ~2/3 reach full or partial success; +7% announcement return with no reversal; payout, operating performance and CEO turnover all rise.</a:t>
-            </a:r>
-          </a:p>
-        </p:txBody>
-      </p:sp>
-      <p:sp>
-        <p:nvSpPr>
-          <p:cNvPr id="22" name="Rectangle 21"/>
+              <a:rPr sz="880" b="0" i="0">
+                <a:solidFill>
+                  <a:srgbClr val="556A83"/>
+                </a:solidFill>
+                <a:latin typeface="Arial"/>
+              </a:rPr>
+              <a:t>Long, but fragile and under-resourced</a:t>
+            </a:r>
+          </a:p>
+        </p:txBody>
+      </p:sp>
+      <p:sp>
+        <p:nvSpPr>
+          <p:cNvPr id="30" name="Rectangle 29"/>
           <p:cNvSpPr/>
           <p:nvPr/>
         </p:nvSpPr>
         <p:spPr>
           <a:xfrm>
-            <a:off x="438922" y="3521049"/>
-            <a:ext cx="2450653" cy="838809"/>
+            <a:off x="4608691" y="3443020"/>
+            <a:ext cx="2560384" cy="760780"/>
+          </a:xfrm>
+          <a:prstGeom prst="rect">
+            <a:avLst/>
+          </a:prstGeom>
+          <a:solidFill>
+            <a:srgbClr val="E2E5E9"/>
+          </a:solidFill>
+          <a:ln>
+            <a:noFill/>
+          </a:ln>
+          <a:effectLst/>
+        </p:spPr>
+        <p:style>
+          <a:lnRef idx="1">
+            <a:schemeClr val="accent1"/>
+          </a:lnRef>
+          <a:fillRef idx="3">
+            <a:schemeClr val="accent1"/>
+          </a:fillRef>
+          <a:effectRef idx="2">
+            <a:schemeClr val="accent1"/>
+          </a:effectRef>
+          <a:fontRef idx="minor">
+            <a:schemeClr val="lt1"/>
+          </a:fontRef>
+        </p:style>
+        <p:txBody>
+          <a:bodyPr rtlCol="0" anchor="ctr"/>
+          <a:lstStyle/>
+          <a:p>
+            <a:pPr algn="ctr"/>
+            <a:endParaRPr/>
+          </a:p>
+        </p:txBody>
+      </p:sp>
+      <p:sp>
+        <p:nvSpPr>
+          <p:cNvPr id="31" name="TextBox 30"/>
+          <p:cNvSpPr txBox="1"/>
+          <p:nvPr/>
+        </p:nvSpPr>
+        <p:spPr>
+          <a:xfrm>
+            <a:off x="4696475" y="3443020"/>
+            <a:ext cx="2414076" cy="760780"/>
+          </a:xfrm>
+          <a:prstGeom prst="rect">
+            <a:avLst/>
+          </a:prstGeom>
+          <a:noFill/>
+        </p:spPr>
+        <p:txBody>
+          <a:bodyPr wrap="square" lIns="0" tIns="0" rIns="0" bIns="0" anchor="ctr">
+            <a:spAutoFit/>
+          </a:bodyPr>
+          <a:lstStyle/>
+          <a:p>
+            <a:pPr algn="l">
+              <a:lnSpc>
+                <a:spcPct val="105000"/>
+              </a:lnSpc>
+              <a:spcAft>
+                <a:spcPts val="0"/>
+              </a:spcAft>
+            </a:pPr>
+            <a:r>
+              <a:rPr sz="880" b="1" i="0">
+                <a:solidFill>
+                  <a:srgbClr val="314359"/>
+                </a:solidFill>
+                <a:latin typeface="Arial"/>
+              </a:rPr>
+              <a:t>Still long — small enough to compound for years</a:t>
+            </a:r>
+          </a:p>
+        </p:txBody>
+      </p:sp>
+      <p:sp>
+        <p:nvSpPr>
+          <p:cNvPr id="32" name="Rectangle 31"/>
+          <p:cNvSpPr/>
+          <p:nvPr/>
+        </p:nvSpPr>
+        <p:spPr>
+          <a:xfrm>
+            <a:off x="7169075" y="3443020"/>
+            <a:ext cx="2121461" cy="760780"/>
+          </a:xfrm>
+          <a:prstGeom prst="rect">
+            <a:avLst/>
+          </a:prstGeom>
+          <a:solidFill>
+            <a:srgbClr val="F6F7F9"/>
+          </a:solidFill>
+          <a:ln>
+            <a:noFill/>
+          </a:ln>
+          <a:effectLst/>
+        </p:spPr>
+        <p:style>
+          <a:lnRef idx="1">
+            <a:schemeClr val="accent1"/>
+          </a:lnRef>
+          <a:fillRef idx="3">
+            <a:schemeClr val="accent1"/>
+          </a:fillRef>
+          <a:effectRef idx="2">
+            <a:schemeClr val="accent1"/>
+          </a:effectRef>
+          <a:fontRef idx="minor">
+            <a:schemeClr val="lt1"/>
+          </a:fontRef>
+        </p:style>
+        <p:txBody>
+          <a:bodyPr rtlCol="0" anchor="ctr"/>
+          <a:lstStyle/>
+          <a:p>
+            <a:pPr algn="ctr"/>
+            <a:endParaRPr/>
+          </a:p>
+        </p:txBody>
+      </p:sp>
+      <p:sp>
+        <p:nvSpPr>
+          <p:cNvPr id="33" name="TextBox 32"/>
+          <p:cNvSpPr txBox="1"/>
+          <p:nvPr/>
+        </p:nvSpPr>
+        <p:spPr>
+          <a:xfrm>
+            <a:off x="7256859" y="3443020"/>
+            <a:ext cx="1975153" cy="760780"/>
+          </a:xfrm>
+          <a:prstGeom prst="rect">
+            <a:avLst/>
+          </a:prstGeom>
+          <a:noFill/>
+        </p:spPr>
+        <p:txBody>
+          <a:bodyPr wrap="square" lIns="0" tIns="0" rIns="0" bIns="0" anchor="ctr">
+            <a:spAutoFit/>
+          </a:bodyPr>
+          <a:lstStyle/>
+          <a:p>
+            <a:pPr algn="l">
+              <a:lnSpc>
+                <a:spcPct val="105000"/>
+              </a:lnSpc>
+              <a:spcAft>
+                <a:spcPts val="0"/>
+              </a:spcAft>
+            </a:pPr>
+            <a:r>
+              <a:rPr sz="880" b="0" i="0">
+                <a:solidFill>
+                  <a:srgbClr val="556A83"/>
+                </a:solidFill>
+                <a:latin typeface="Arial"/>
+              </a:rPr>
+              <a:t>Largely played out; growth is incremental</a:t>
+            </a:r>
+          </a:p>
+        </p:txBody>
+      </p:sp>
+      <p:sp>
+        <p:nvSpPr>
+          <p:cNvPr id="34" name="Rectangle 33"/>
+          <p:cNvSpPr/>
+          <p:nvPr/>
+        </p:nvSpPr>
+        <p:spPr>
+          <a:xfrm>
+            <a:off x="402346" y="4203801"/>
+            <a:ext cx="1828845" cy="760780"/>
           </a:xfrm>
           <a:prstGeom prst="rect">
             <a:avLst/>
@@ -27393,14 +27907,14 @@
       </p:sp>
       <p:sp>
         <p:nvSpPr>
-          <p:cNvPr id="23" name="TextBox 22"/>
-          <p:cNvSpPr txBox="1"/>
-          <p:nvPr/>
-        </p:nvSpPr>
-        <p:spPr>
-          <a:xfrm>
-            <a:off x="534022" y="3521049"/>
-            <a:ext cx="2275084" cy="838809"/>
+          <p:cNvPr id="35" name="TextBox 34"/>
+          <p:cNvSpPr txBox="1"/>
+          <p:nvPr/>
+        </p:nvSpPr>
+        <p:spPr>
+          <a:xfrm>
+            <a:off x="490130" y="4203801"/>
+            <a:ext cx="1682538" cy="760780"/>
           </a:xfrm>
           <a:prstGeom prst="rect">
             <a:avLst/>
@@ -27415,34 +27929,34 @@
           <a:p>
             <a:pPr algn="l">
               <a:lnSpc>
-                <a:spcPct val="108000"/>
+                <a:spcPct val="105000"/>
               </a:lnSpc>
               <a:spcAft>
                 <a:spcPts val="0"/>
               </a:spcAft>
             </a:pPr>
             <a:r>
-              <a:rPr sz="800" b="1" i="0">
+              <a:rPr sz="880" b="1" i="0">
                 <a:solidFill>
                   <a:srgbClr val="314359"/>
                 </a:solidFill>
                 <a:latin typeface="Arial"/>
               </a:rPr>
-              <a:t>Becht, Franks, Grant &amp; Wagner (2017) · Rev. Fin. Studies</a:t>
-            </a:r>
-          </a:p>
-        </p:txBody>
-      </p:sp>
-      <p:sp>
-        <p:nvSpPr>
-          <p:cNvPr id="24" name="Rectangle 23"/>
+              <a:t>Speed of change</a:t>
+            </a:r>
+          </a:p>
+        </p:txBody>
+      </p:sp>
+      <p:sp>
+        <p:nvSpPr>
+          <p:cNvPr id="36" name="Rectangle 35"/>
           <p:cNvSpPr/>
           <p:nvPr/>
         </p:nvSpPr>
         <p:spPr>
           <a:xfrm>
-            <a:off x="2889576" y="3521049"/>
-            <a:ext cx="1865422" cy="838809"/>
+            <a:off x="2231191" y="4203801"/>
+            <a:ext cx="2377499" cy="760780"/>
           </a:xfrm>
           <a:prstGeom prst="rect">
             <a:avLst/>
@@ -27480,14 +27994,14 @@
       </p:sp>
       <p:sp>
         <p:nvSpPr>
-          <p:cNvPr id="25" name="TextBox 24"/>
-          <p:cNvSpPr txBox="1"/>
-          <p:nvPr/>
-        </p:nvSpPr>
-        <p:spPr>
-          <a:xfrm>
-            <a:off x="2984676" y="3521049"/>
-            <a:ext cx="1689853" cy="838809"/>
+          <p:cNvPr id="37" name="TextBox 36"/>
+          <p:cNvSpPr txBox="1"/>
+          <p:nvPr/>
+        </p:nvSpPr>
+        <p:spPr>
+          <a:xfrm>
+            <a:off x="2318976" y="4203801"/>
+            <a:ext cx="2231191" cy="760780"/>
           </a:xfrm>
           <a:prstGeom prst="rect">
             <a:avLst/>
@@ -27502,34 +28016,121 @@
           <a:p>
             <a:pPr algn="l">
               <a:lnSpc>
-                <a:spcPct val="108000"/>
+                <a:spcPct val="105000"/>
               </a:lnSpc>
               <a:spcAft>
                 <a:spcPts val="0"/>
               </a:spcAft>
             </a:pPr>
             <a:r>
-              <a:rPr sz="760" b="0" i="0">
-                <a:solidFill>
-                  <a:srgbClr val="0E1620"/>
-                </a:solidFill>
-                <a:latin typeface="Arial"/>
-              </a:rPr>
-              <a:t>1,740 engagements, 23 countries</a:t>
-            </a:r>
-          </a:p>
-        </p:txBody>
-      </p:sp>
-      <p:sp>
-        <p:nvSpPr>
-          <p:cNvPr id="26" name="Rectangle 25"/>
+              <a:rPr sz="880" b="0" i="0">
+                <a:solidFill>
+                  <a:srgbClr val="556A83"/>
+                </a:solidFill>
+                <a:latin typeface="Arial"/>
+              </a:rPr>
+              <a:t>Fast, but limited resources to execute</a:t>
+            </a:r>
+          </a:p>
+        </p:txBody>
+      </p:sp>
+      <p:sp>
+        <p:nvSpPr>
+          <p:cNvPr id="38" name="Rectangle 37"/>
           <p:cNvSpPr/>
           <p:nvPr/>
         </p:nvSpPr>
         <p:spPr>
           <a:xfrm>
-            <a:off x="4754998" y="3521049"/>
-            <a:ext cx="4579429" cy="838809"/>
+            <a:off x="4608691" y="4203801"/>
+            <a:ext cx="2560384" cy="760780"/>
+          </a:xfrm>
+          <a:prstGeom prst="rect">
+            <a:avLst/>
+          </a:prstGeom>
+          <a:solidFill>
+            <a:srgbClr val="F6F7F9"/>
+          </a:solidFill>
+          <a:ln>
+            <a:noFill/>
+          </a:ln>
+          <a:effectLst/>
+        </p:spPr>
+        <p:style>
+          <a:lnRef idx="1">
+            <a:schemeClr val="accent1"/>
+          </a:lnRef>
+          <a:fillRef idx="3">
+            <a:schemeClr val="accent1"/>
+          </a:fillRef>
+          <a:effectRef idx="2">
+            <a:schemeClr val="accent1"/>
+          </a:effectRef>
+          <a:fontRef idx="minor">
+            <a:schemeClr val="lt1"/>
+          </a:fontRef>
+        </p:style>
+        <p:txBody>
+          <a:bodyPr rtlCol="0" anchor="ctr"/>
+          <a:lstStyle/>
+          <a:p>
+            <a:pPr algn="ctr"/>
+            <a:endParaRPr/>
+          </a:p>
+        </p:txBody>
+      </p:sp>
+      <p:sp>
+        <p:nvSpPr>
+          <p:cNvPr id="39" name="TextBox 38"/>
+          <p:cNvSpPr txBox="1"/>
+          <p:nvPr/>
+        </p:nvSpPr>
+        <p:spPr>
+          <a:xfrm>
+            <a:off x="4696475" y="4203801"/>
+            <a:ext cx="2414076" cy="760780"/>
+          </a:xfrm>
+          <a:prstGeom prst="rect">
+            <a:avLst/>
+          </a:prstGeom>
+          <a:noFill/>
+        </p:spPr>
+        <p:txBody>
+          <a:bodyPr wrap="square" lIns="0" tIns="0" rIns="0" bIns="0" anchor="ctr">
+            <a:spAutoFit/>
+          </a:bodyPr>
+          <a:lstStyle/>
+          <a:p>
+            <a:pPr algn="l">
+              <a:lnSpc>
+                <a:spcPct val="105000"/>
+              </a:lnSpc>
+              <a:spcAft>
+                <a:spcPts val="0"/>
+              </a:spcAft>
+            </a:pPr>
+            <a:r>
+              <a:rPr sz="880" b="1" i="0">
+                <a:solidFill>
+                  <a:srgbClr val="314359"/>
+                </a:solidFill>
+                <a:latin typeface="Arial"/>
+              </a:rPr>
+              <a:t>Operational change lands within ~1.5 years</a:t>
+            </a:r>
+          </a:p>
+        </p:txBody>
+      </p:sp>
+      <p:sp>
+        <p:nvSpPr>
+          <p:cNvPr id="40" name="Rectangle 39"/>
+          <p:cNvSpPr/>
+          <p:nvPr/>
+        </p:nvSpPr>
+        <p:spPr>
+          <a:xfrm>
+            <a:off x="7169075" y="4203801"/>
+            <a:ext cx="2121461" cy="760780"/>
           </a:xfrm>
           <a:prstGeom prst="rect">
             <a:avLst/>
@@ -27567,14 +28168,14 @@
       </p:sp>
       <p:sp>
         <p:nvSpPr>
-          <p:cNvPr id="27" name="TextBox 26"/>
-          <p:cNvSpPr txBox="1"/>
-          <p:nvPr/>
-        </p:nvSpPr>
-        <p:spPr>
-          <a:xfrm>
-            <a:off x="4850098" y="3521049"/>
-            <a:ext cx="4403860" cy="838809"/>
+          <p:cNvPr id="41" name="TextBox 40"/>
+          <p:cNvSpPr txBox="1"/>
+          <p:nvPr/>
+        </p:nvSpPr>
+        <p:spPr>
+          <a:xfrm>
+            <a:off x="7256859" y="4203801"/>
+            <a:ext cx="1975153" cy="760780"/>
           </a:xfrm>
           <a:prstGeom prst="rect">
             <a:avLst/>
@@ -27589,34 +28190,34 @@
           <a:p>
             <a:pPr algn="l">
               <a:lnSpc>
-                <a:spcPct val="108000"/>
+                <a:spcPct val="105000"/>
               </a:lnSpc>
               <a:spcAft>
                 <a:spcPts val="0"/>
               </a:spcAft>
             </a:pPr>
             <a:r>
-              <a:rPr sz="760" b="0" i="0">
-                <a:solidFill>
-                  <a:srgbClr val="0E1620"/>
-                </a:solidFill>
-                <a:latin typeface="Arial"/>
-              </a:rPr>
-              <a:t>Outcomes and market responses are similar in Europe and North America — the playbook travels; board representation is a central, value-creating outcome.</a:t>
-            </a:r>
-          </a:p>
-        </p:txBody>
-      </p:sp>
-      <p:sp>
-        <p:nvSpPr>
-          <p:cNvPr id="28" name="Rectangle 27"/>
+              <a:rPr sz="880" b="0" i="0">
+                <a:solidFill>
+                  <a:srgbClr val="556A83"/>
+                </a:solidFill>
+                <a:latin typeface="Arial"/>
+              </a:rPr>
+              <a:t>Years to turn; entrenched complexity</a:t>
+            </a:r>
+          </a:p>
+        </p:txBody>
+      </p:sp>
+      <p:sp>
+        <p:nvSpPr>
+          <p:cNvPr id="42" name="Rectangle 41"/>
           <p:cNvSpPr/>
           <p:nvPr/>
         </p:nvSpPr>
         <p:spPr>
           <a:xfrm>
-            <a:off x="438922" y="4359859"/>
-            <a:ext cx="2450653" cy="838809"/>
+            <a:off x="402346" y="4964582"/>
+            <a:ext cx="1828845" cy="760780"/>
           </a:xfrm>
           <a:prstGeom prst="rect">
             <a:avLst/>
@@ -27654,14 +28255,14 @@
       </p:sp>
       <p:sp>
         <p:nvSpPr>
-          <p:cNvPr id="29" name="TextBox 28"/>
-          <p:cNvSpPr txBox="1"/>
-          <p:nvPr/>
-        </p:nvSpPr>
-        <p:spPr>
-          <a:xfrm>
-            <a:off x="534022" y="4359859"/>
-            <a:ext cx="2275084" cy="838809"/>
+          <p:cNvPr id="43" name="TextBox 42"/>
+          <p:cNvSpPr txBox="1"/>
+          <p:nvPr/>
+        </p:nvSpPr>
+        <p:spPr>
+          <a:xfrm>
+            <a:off x="490130" y="4964582"/>
+            <a:ext cx="1682538" cy="760780"/>
           </a:xfrm>
           <a:prstGeom prst="rect">
             <a:avLst/>
@@ -27676,34 +28277,34 @@
           <a:p>
             <a:pPr algn="l">
               <a:lnSpc>
-                <a:spcPct val="108000"/>
+                <a:spcPct val="105000"/>
               </a:lnSpc>
               <a:spcAft>
                 <a:spcPts val="0"/>
               </a:spcAft>
             </a:pPr>
             <a:r>
-              <a:rPr sz="800" b="1" i="0">
+              <a:rPr sz="880" b="1" i="0">
                 <a:solidFill>
                   <a:srgbClr val="314359"/>
                 </a:solidFill>
                 <a:latin typeface="Arial"/>
               </a:rPr>
-              <a:t>Becht, Franks, Mayer &amp; Rossi (2009) · Rev. Fin. Studies</a:t>
-            </a:r>
-          </a:p>
-        </p:txBody>
-      </p:sp>
-      <p:sp>
-        <p:nvSpPr>
-          <p:cNvPr id="30" name="Rectangle 29"/>
+              <a:t>Owner influence</a:t>
+            </a:r>
+          </a:p>
+        </p:txBody>
+      </p:sp>
+      <p:sp>
+        <p:nvSpPr>
+          <p:cNvPr id="44" name="Rectangle 43"/>
           <p:cNvSpPr/>
           <p:nvPr/>
         </p:nvSpPr>
         <p:spPr>
           <a:xfrm>
-            <a:off x="2889576" y="4359859"/>
-            <a:ext cx="1865422" cy="838809"/>
+            <a:off x="2231191" y="4964582"/>
+            <a:ext cx="2377499" cy="760780"/>
           </a:xfrm>
           <a:prstGeom prst="rect">
             <a:avLst/>
@@ -27741,14 +28342,14 @@
       </p:sp>
       <p:sp>
         <p:nvSpPr>
-          <p:cNvPr id="31" name="TextBox 30"/>
-          <p:cNvSpPr txBox="1"/>
-          <p:nvPr/>
-        </p:nvSpPr>
-        <p:spPr>
-          <a:xfrm>
-            <a:off x="2984676" y="4359859"/>
-            <a:ext cx="1689853" cy="838809"/>
+          <p:cNvPr id="45" name="TextBox 44"/>
+          <p:cNvSpPr txBox="1"/>
+          <p:nvPr/>
+        </p:nvSpPr>
+        <p:spPr>
+          <a:xfrm>
+            <a:off x="2318976" y="4964582"/>
+            <a:ext cx="2231191" cy="760780"/>
           </a:xfrm>
           <a:prstGeom prst="rect">
             <a:avLst/>
@@ -27763,34 +28364,121 @@
           <a:p>
             <a:pPr algn="l">
               <a:lnSpc>
-                <a:spcPct val="108000"/>
+                <a:spcPct val="105000"/>
               </a:lnSpc>
               <a:spcAft>
                 <a:spcPts val="0"/>
               </a:spcAft>
             </a:pPr>
             <a:r>
-              <a:rPr sz="760" b="0" i="0">
-                <a:solidFill>
-                  <a:srgbClr val="0E1620"/>
-                </a:solidFill>
-                <a:latin typeface="Arial"/>
-              </a:rPr>
-              <a:t>Clinical study — Hermes UK Focus Fund</a:t>
-            </a:r>
-          </a:p>
-        </p:txBody>
-      </p:sp>
-      <p:sp>
-        <p:nvSpPr>
-          <p:cNvPr id="32" name="Rectangle 31"/>
+              <a:rPr sz="880" b="0" i="0">
+                <a:solidFill>
+                  <a:srgbClr val="556A83"/>
+                </a:solidFill>
+                <a:latin typeface="Arial"/>
+              </a:rPr>
+              <a:t>High, but little to work with</a:t>
+            </a:r>
+          </a:p>
+        </p:txBody>
+      </p:sp>
+      <p:sp>
+        <p:nvSpPr>
+          <p:cNvPr id="46" name="Rectangle 45"/>
           <p:cNvSpPr/>
           <p:nvPr/>
         </p:nvSpPr>
         <p:spPr>
           <a:xfrm>
-            <a:off x="4754998" y="4359859"/>
-            <a:ext cx="4579429" cy="838809"/>
+            <a:off x="4608691" y="4964582"/>
+            <a:ext cx="2560384" cy="760780"/>
+          </a:xfrm>
+          <a:prstGeom prst="rect">
+            <a:avLst/>
+          </a:prstGeom>
+          <a:solidFill>
+            <a:srgbClr val="E2E5E9"/>
+          </a:solidFill>
+          <a:ln>
+            <a:noFill/>
+          </a:ln>
+          <a:effectLst/>
+        </p:spPr>
+        <p:style>
+          <a:lnRef idx="1">
+            <a:schemeClr val="accent1"/>
+          </a:lnRef>
+          <a:fillRef idx="3">
+            <a:schemeClr val="accent1"/>
+          </a:fillRef>
+          <a:effectRef idx="2">
+            <a:schemeClr val="accent1"/>
+          </a:effectRef>
+          <a:fontRef idx="minor">
+            <a:schemeClr val="lt1"/>
+          </a:fontRef>
+        </p:style>
+        <p:txBody>
+          <a:bodyPr rtlCol="0" anchor="ctr"/>
+          <a:lstStyle/>
+          <a:p>
+            <a:pPr algn="ctr"/>
+            <a:endParaRPr/>
+          </a:p>
+        </p:txBody>
+      </p:sp>
+      <p:sp>
+        <p:nvSpPr>
+          <p:cNvPr id="47" name="TextBox 46"/>
+          <p:cNvSpPr txBox="1"/>
+          <p:nvPr/>
+        </p:nvSpPr>
+        <p:spPr>
+          <a:xfrm>
+            <a:off x="4696475" y="4964582"/>
+            <a:ext cx="2414076" cy="760780"/>
+          </a:xfrm>
+          <a:prstGeom prst="rect">
+            <a:avLst/>
+          </a:prstGeom>
+          <a:noFill/>
+        </p:spPr>
+        <p:txBody>
+          <a:bodyPr wrap="square" lIns="0" tIns="0" rIns="0" bIns="0" anchor="ctr">
+            <a:spAutoFit/>
+          </a:bodyPr>
+          <a:lstStyle/>
+          <a:p>
+            <a:pPr algn="l">
+              <a:lnSpc>
+                <a:spcPct val="105000"/>
+              </a:lnSpc>
+              <a:spcAft>
+                <a:spcPts val="0"/>
+              </a:spcAft>
+            </a:pPr>
+            <a:r>
+              <a:rPr sz="880" b="1" i="0">
+                <a:solidFill>
+                  <a:srgbClr val="314359"/>
+                </a:solidFill>
+                <a:latin typeface="Arial"/>
+              </a:rPr>
+              <a:t>A board seat genuinely moves the outcome</a:t>
+            </a:r>
+          </a:p>
+        </p:txBody>
+      </p:sp>
+      <p:sp>
+        <p:nvSpPr>
+          <p:cNvPr id="48" name="Rectangle 47"/>
+          <p:cNvSpPr/>
+          <p:nvPr/>
+        </p:nvSpPr>
+        <p:spPr>
+          <a:xfrm>
+            <a:off x="7169075" y="4964582"/>
+            <a:ext cx="2121461" cy="760780"/>
           </a:xfrm>
           <a:prstGeom prst="rect">
             <a:avLst/>
@@ -27828,14 +28516,14 @@
       </p:sp>
       <p:sp>
         <p:nvSpPr>
-          <p:cNvPr id="33" name="TextBox 32"/>
-          <p:cNvSpPr txBox="1"/>
-          <p:nvPr/>
-        </p:nvSpPr>
-        <p:spPr>
-          <a:xfrm>
-            <a:off x="4850098" y="4359859"/>
-            <a:ext cx="4403860" cy="838809"/>
+          <p:cNvPr id="49" name="TextBox 48"/>
+          <p:cNvSpPr txBox="1"/>
+          <p:nvPr/>
+        </p:nvSpPr>
+        <p:spPr>
+          <a:xfrm>
+            <a:off x="7256859" y="4964582"/>
+            <a:ext cx="1975153" cy="760780"/>
           </a:xfrm>
           <a:prstGeom prst="rect">
             <a:avLst/>
@@ -27850,584 +28538,104 @@
           <a:p>
             <a:pPr algn="l">
               <a:lnSpc>
-                <a:spcPct val="108000"/>
+                <a:spcPct val="105000"/>
               </a:lnSpc>
               <a:spcAft>
                 <a:spcPts val="0"/>
               </a:spcAft>
             </a:pPr>
             <a:r>
+              <a:rPr sz="880" b="0" i="0">
+                <a:solidFill>
+                  <a:srgbClr val="556A83"/>
+                </a:solidFill>
+                <a:latin typeface="Arial"/>
+              </a:rPr>
+              <a:t>Diluted; one owner rarely shifts the agenda</a:t>
+            </a:r>
+          </a:p>
+        </p:txBody>
+      </p:sp>
+      <p:sp>
+        <p:nvSpPr>
+          <p:cNvPr id="50" name="TextBox 49"/>
+          <p:cNvSpPr txBox="1"/>
+          <p:nvPr/>
+        </p:nvSpPr>
+        <p:spPr>
+          <a:xfrm>
+            <a:off x="402346" y="5861913"/>
+            <a:ext cx="8924767" cy="409651"/>
+          </a:xfrm>
+          <a:prstGeom prst="rect">
+            <a:avLst/>
+          </a:prstGeom>
+          <a:noFill/>
+        </p:spPr>
+        <p:txBody>
+          <a:bodyPr wrap="square" lIns="0" tIns="0" rIns="0" bIns="0" anchor="t">
+            <a:spAutoFit/>
+          </a:bodyPr>
+          <a:lstStyle/>
+          <a:p>
+            <a:pPr algn="l">
+              <a:lnSpc>
+                <a:spcPct val="110000"/>
+              </a:lnSpc>
+              <a:spcAft>
+                <a:spcPts val="0"/>
+              </a:spcAft>
+            </a:pPr>
+            <a:r>
+              <a:rPr sz="1040" b="0" i="1">
+                <a:solidFill>
+                  <a:srgbClr val="314359"/>
+                </a:solidFill>
+                <a:latin typeface="Arial"/>
+              </a:rPr>
+              <a:t>Mid-market companies are run well enough to be worth owning, yet small enough that an engaged owner can still change — and grow — them.</a:t>
+            </a:r>
+          </a:p>
+        </p:txBody>
+      </p:sp>
+      <p:sp>
+        <p:nvSpPr>
+          <p:cNvPr id="51" name="TextBox 50"/>
+          <p:cNvSpPr txBox="1"/>
+          <p:nvPr/>
+        </p:nvSpPr>
+        <p:spPr>
+          <a:xfrm>
+            <a:off x="402346" y="6369100"/>
+            <a:ext cx="8924767" cy="585216"/>
+          </a:xfrm>
+          <a:prstGeom prst="rect">
+            <a:avLst/>
+          </a:prstGeom>
+          <a:noFill/>
+        </p:spPr>
+        <p:txBody>
+          <a:bodyPr wrap="square" lIns="0" tIns="0" rIns="0" bIns="0" anchor="t">
+            <a:spAutoFit/>
+          </a:bodyPr>
+          <a:lstStyle/>
+          <a:p>
+            <a:pPr algn="l">
+              <a:lnSpc>
+                <a:spcPct val="116000"/>
+              </a:lnSpc>
+              <a:spcAft>
+                <a:spcPts val="0"/>
+              </a:spcAft>
+            </a:pPr>
+            <a:r>
               <a:rPr sz="760" b="0" i="0">
                 <a:solidFill>
-                  <a:srgbClr val="0E1620"/>
-                </a:solidFill>
-                <a:latin typeface="Arial"/>
-              </a:rPr>
-              <a:t>Returns come from engagement, not stock-picking — via private, cooperative interventions: refocus on the core, return cash, change the CEO / chair.</a:t>
-            </a:r>
-          </a:p>
-        </p:txBody>
-      </p:sp>
-      <p:sp>
-        <p:nvSpPr>
-          <p:cNvPr id="34" name="Rectangle 33"/>
-          <p:cNvSpPr/>
-          <p:nvPr/>
-        </p:nvSpPr>
-        <p:spPr>
-          <a:xfrm>
-            <a:off x="438922" y="5198668"/>
-            <a:ext cx="2450653" cy="838809"/>
-          </a:xfrm>
-          <a:prstGeom prst="rect">
-            <a:avLst/>
-          </a:prstGeom>
-          <a:solidFill>
-            <a:srgbClr val="FFFFFF"/>
-          </a:solidFill>
-          <a:ln>
-            <a:noFill/>
-          </a:ln>
-          <a:effectLst/>
-        </p:spPr>
-        <p:style>
-          <a:lnRef idx="1">
-            <a:schemeClr val="accent1"/>
-          </a:lnRef>
-          <a:fillRef idx="3">
-            <a:schemeClr val="accent1"/>
-          </a:fillRef>
-          <a:effectRef idx="2">
-            <a:schemeClr val="accent1"/>
-          </a:effectRef>
-          <a:fontRef idx="minor">
-            <a:schemeClr val="lt1"/>
-          </a:fontRef>
-        </p:style>
-        <p:txBody>
-          <a:bodyPr rtlCol="0" anchor="ctr"/>
-          <a:lstStyle/>
-          <a:p>
-            <a:pPr algn="ctr"/>
-            <a:endParaRPr/>
-          </a:p>
-        </p:txBody>
-      </p:sp>
-      <p:sp>
-        <p:nvSpPr>
-          <p:cNvPr id="35" name="TextBox 34"/>
-          <p:cNvSpPr txBox="1"/>
-          <p:nvPr/>
-        </p:nvSpPr>
-        <p:spPr>
-          <a:xfrm>
-            <a:off x="534022" y="5198668"/>
-            <a:ext cx="2275084" cy="838809"/>
-          </a:xfrm>
-          <a:prstGeom prst="rect">
-            <a:avLst/>
-          </a:prstGeom>
-          <a:noFill/>
-        </p:spPr>
-        <p:txBody>
-          <a:bodyPr wrap="square" lIns="0" tIns="0" rIns="0" bIns="0" anchor="ctr">
-            <a:spAutoFit/>
-          </a:bodyPr>
-          <a:lstStyle/>
-          <a:p>
-            <a:pPr algn="l">
-              <a:lnSpc>
-                <a:spcPct val="108000"/>
-              </a:lnSpc>
-              <a:spcAft>
-                <a:spcPts val="0"/>
-              </a:spcAft>
-            </a:pPr>
-            <a:r>
-              <a:rPr sz="800" b="1" i="0">
-                <a:solidFill>
-                  <a:srgbClr val="314359"/>
-                </a:solidFill>
-                <a:latin typeface="Arial"/>
-              </a:rPr>
-              <a:t>Bebchuk, Brav, Jiang &amp; Keusch (2020) · J. Fin. Economics</a:t>
-            </a:r>
-          </a:p>
-        </p:txBody>
-      </p:sp>
-      <p:sp>
-        <p:nvSpPr>
-          <p:cNvPr id="36" name="Rectangle 35"/>
-          <p:cNvSpPr/>
-          <p:nvPr/>
-        </p:nvSpPr>
-        <p:spPr>
-          <a:xfrm>
-            <a:off x="2889576" y="5198668"/>
-            <a:ext cx="1865422" cy="838809"/>
-          </a:xfrm>
-          <a:prstGeom prst="rect">
-            <a:avLst/>
-          </a:prstGeom>
-          <a:solidFill>
-            <a:srgbClr val="FFFFFF"/>
-          </a:solidFill>
-          <a:ln>
-            <a:noFill/>
-          </a:ln>
-          <a:effectLst/>
-        </p:spPr>
-        <p:style>
-          <a:lnRef idx="1">
-            <a:schemeClr val="accent1"/>
-          </a:lnRef>
-          <a:fillRef idx="3">
-            <a:schemeClr val="accent1"/>
-          </a:fillRef>
-          <a:effectRef idx="2">
-            <a:schemeClr val="accent1"/>
-          </a:effectRef>
-          <a:fontRef idx="minor">
-            <a:schemeClr val="lt1"/>
-          </a:fontRef>
-        </p:style>
-        <p:txBody>
-          <a:bodyPr rtlCol="0" anchor="ctr"/>
-          <a:lstStyle/>
-          <a:p>
-            <a:pPr algn="ctr"/>
-            <a:endParaRPr/>
-          </a:p>
-        </p:txBody>
-      </p:sp>
-      <p:sp>
-        <p:nvSpPr>
-          <p:cNvPr id="37" name="TextBox 36"/>
-          <p:cNvSpPr txBox="1"/>
-          <p:nvPr/>
-        </p:nvSpPr>
-        <p:spPr>
-          <a:xfrm>
-            <a:off x="2984676" y="5198668"/>
-            <a:ext cx="1689853" cy="838809"/>
-          </a:xfrm>
-          <a:prstGeom prst="rect">
-            <a:avLst/>
-          </a:prstGeom>
-          <a:noFill/>
-        </p:spPr>
-        <p:txBody>
-          <a:bodyPr wrap="square" lIns="0" tIns="0" rIns="0" bIns="0" anchor="ctr">
-            <a:spAutoFit/>
-          </a:bodyPr>
-          <a:lstStyle/>
-          <a:p>
-            <a:pPr algn="l">
-              <a:lnSpc>
-                <a:spcPct val="108000"/>
-              </a:lnSpc>
-              <a:spcAft>
-                <a:spcPts val="0"/>
-              </a:spcAft>
-            </a:pPr>
-            <a:r>
-              <a:rPr sz="760" b="0" i="0">
-                <a:solidFill>
-                  <a:srgbClr val="0E1620"/>
-                </a:solidFill>
-                <a:latin typeface="Arial"/>
-              </a:rPr>
-              <a:t>US settlement agreements</a:t>
-            </a:r>
-          </a:p>
-        </p:txBody>
-      </p:sp>
-      <p:sp>
-        <p:nvSpPr>
-          <p:cNvPr id="38" name="Rectangle 37"/>
-          <p:cNvSpPr/>
-          <p:nvPr/>
-        </p:nvSpPr>
-        <p:spPr>
-          <a:xfrm>
-            <a:off x="4754998" y="5198668"/>
-            <a:ext cx="4579429" cy="838809"/>
-          </a:xfrm>
-          <a:prstGeom prst="rect">
-            <a:avLst/>
-          </a:prstGeom>
-          <a:solidFill>
-            <a:srgbClr val="FFFFFF"/>
-          </a:solidFill>
-          <a:ln>
-            <a:noFill/>
-          </a:ln>
-          <a:effectLst/>
-        </p:spPr>
-        <p:style>
-          <a:lnRef idx="1">
-            <a:schemeClr val="accent1"/>
-          </a:lnRef>
-          <a:fillRef idx="3">
-            <a:schemeClr val="accent1"/>
-          </a:fillRef>
-          <a:effectRef idx="2">
-            <a:schemeClr val="accent1"/>
-          </a:effectRef>
-          <a:fontRef idx="minor">
-            <a:schemeClr val="lt1"/>
-          </a:fontRef>
-        </p:style>
-        <p:txBody>
-          <a:bodyPr rtlCol="0" anchor="ctr"/>
-          <a:lstStyle/>
-          <a:p>
-            <a:pPr algn="ctr"/>
-            <a:endParaRPr/>
-          </a:p>
-        </p:txBody>
-      </p:sp>
-      <p:sp>
-        <p:nvSpPr>
-          <p:cNvPr id="39" name="TextBox 38"/>
-          <p:cNvSpPr txBox="1"/>
-          <p:nvPr/>
-        </p:nvSpPr>
-        <p:spPr>
-          <a:xfrm>
-            <a:off x="4850098" y="5198668"/>
-            <a:ext cx="4403860" cy="838809"/>
-          </a:xfrm>
-          <a:prstGeom prst="rect">
-            <a:avLst/>
-          </a:prstGeom>
-          <a:noFill/>
-        </p:spPr>
-        <p:txBody>
-          <a:bodyPr wrap="square" lIns="0" tIns="0" rIns="0" bIns="0" anchor="ctr">
-            <a:spAutoFit/>
-          </a:bodyPr>
-          <a:lstStyle/>
-          <a:p>
-            <a:pPr algn="l">
-              <a:lnSpc>
-                <a:spcPct val="108000"/>
-              </a:lnSpc>
-              <a:spcAft>
-                <a:spcPts val="0"/>
-              </a:spcAft>
-            </a:pPr>
-            <a:r>
-              <a:rPr sz="760" b="0" i="0">
-                <a:solidFill>
-                  <a:srgbClr val="0E1620"/>
-                </a:solidFill>
-                <a:latin typeface="Arial"/>
-              </a:rPr>
-              <a:t>Boards settle by granting board seats — the intermediary step to the operational and leadership change activists seek. Exactly the precondition model.</a:t>
-            </a:r>
-          </a:p>
-        </p:txBody>
-      </p:sp>
-      <p:sp>
-        <p:nvSpPr>
-          <p:cNvPr id="40" name="Rectangle 39"/>
-          <p:cNvSpPr/>
-          <p:nvPr/>
-        </p:nvSpPr>
-        <p:spPr>
-          <a:xfrm>
-            <a:off x="438922" y="6037478"/>
-            <a:ext cx="2450653" cy="838809"/>
-          </a:xfrm>
-          <a:prstGeom prst="rect">
-            <a:avLst/>
-          </a:prstGeom>
-          <a:solidFill>
-            <a:srgbClr val="F6F7F9"/>
-          </a:solidFill>
-          <a:ln>
-            <a:noFill/>
-          </a:ln>
-          <a:effectLst/>
-        </p:spPr>
-        <p:style>
-          <a:lnRef idx="1">
-            <a:schemeClr val="accent1"/>
-          </a:lnRef>
-          <a:fillRef idx="3">
-            <a:schemeClr val="accent1"/>
-          </a:fillRef>
-          <a:effectRef idx="2">
-            <a:schemeClr val="accent1"/>
-          </a:effectRef>
-          <a:fontRef idx="minor">
-            <a:schemeClr val="lt1"/>
-          </a:fontRef>
-        </p:style>
-        <p:txBody>
-          <a:bodyPr rtlCol="0" anchor="ctr"/>
-          <a:lstStyle/>
-          <a:p>
-            <a:pPr algn="ctr"/>
-            <a:endParaRPr/>
-          </a:p>
-        </p:txBody>
-      </p:sp>
-      <p:sp>
-        <p:nvSpPr>
-          <p:cNvPr id="41" name="TextBox 40"/>
-          <p:cNvSpPr txBox="1"/>
-          <p:nvPr/>
-        </p:nvSpPr>
-        <p:spPr>
-          <a:xfrm>
-            <a:off x="534022" y="6037478"/>
-            <a:ext cx="2275084" cy="838809"/>
-          </a:xfrm>
-          <a:prstGeom prst="rect">
-            <a:avLst/>
-          </a:prstGeom>
-          <a:noFill/>
-        </p:spPr>
-        <p:txBody>
-          <a:bodyPr wrap="square" lIns="0" tIns="0" rIns="0" bIns="0" anchor="ctr">
-            <a:spAutoFit/>
-          </a:bodyPr>
-          <a:lstStyle/>
-          <a:p>
-            <a:pPr algn="l">
-              <a:lnSpc>
-                <a:spcPct val="108000"/>
-              </a:lnSpc>
-              <a:spcAft>
-                <a:spcPts val="0"/>
-              </a:spcAft>
-            </a:pPr>
-            <a:r>
-              <a:rPr sz="800" b="1" i="0">
-                <a:solidFill>
-                  <a:srgbClr val="314359"/>
-                </a:solidFill>
-                <a:latin typeface="Arial"/>
-              </a:rPr>
-              <a:t>Gantchev (2013) · J. Fin. Economics</a:t>
-            </a:r>
-          </a:p>
-        </p:txBody>
-      </p:sp>
-      <p:sp>
-        <p:nvSpPr>
-          <p:cNvPr id="42" name="Rectangle 41"/>
-          <p:cNvSpPr/>
-          <p:nvPr/>
-        </p:nvSpPr>
-        <p:spPr>
-          <a:xfrm>
-            <a:off x="2889576" y="6037478"/>
-            <a:ext cx="1865422" cy="838809"/>
-          </a:xfrm>
-          <a:prstGeom prst="rect">
-            <a:avLst/>
-          </a:prstGeom>
-          <a:solidFill>
-            <a:srgbClr val="F6F7F9"/>
-          </a:solidFill>
-          <a:ln>
-            <a:noFill/>
-          </a:ln>
-          <a:effectLst/>
-        </p:spPr>
-        <p:style>
-          <a:lnRef idx="1">
-            <a:schemeClr val="accent1"/>
-          </a:lnRef>
-          <a:fillRef idx="3">
-            <a:schemeClr val="accent1"/>
-          </a:fillRef>
-          <a:effectRef idx="2">
-            <a:schemeClr val="accent1"/>
-          </a:effectRef>
-          <a:fontRef idx="minor">
-            <a:schemeClr val="lt1"/>
-          </a:fontRef>
-        </p:style>
-        <p:txBody>
-          <a:bodyPr rtlCol="0" anchor="ctr"/>
-          <a:lstStyle/>
-          <a:p>
-            <a:pPr algn="ctr"/>
-            <a:endParaRPr/>
-          </a:p>
-        </p:txBody>
-      </p:sp>
-      <p:sp>
-        <p:nvSpPr>
-          <p:cNvPr id="43" name="TextBox 42"/>
-          <p:cNvSpPr txBox="1"/>
-          <p:nvPr/>
-        </p:nvSpPr>
-        <p:spPr>
-          <a:xfrm>
-            <a:off x="2984676" y="6037478"/>
-            <a:ext cx="1689853" cy="838809"/>
-          </a:xfrm>
-          <a:prstGeom prst="rect">
-            <a:avLst/>
-          </a:prstGeom>
-          <a:noFill/>
-        </p:spPr>
-        <p:txBody>
-          <a:bodyPr wrap="square" lIns="0" tIns="0" rIns="0" bIns="0" anchor="ctr">
-            <a:spAutoFit/>
-          </a:bodyPr>
-          <a:lstStyle/>
-          <a:p>
-            <a:pPr algn="l">
-              <a:lnSpc>
-                <a:spcPct val="108000"/>
-              </a:lnSpc>
-              <a:spcAft>
-                <a:spcPts val="0"/>
-              </a:spcAft>
-            </a:pPr>
-            <a:r>
-              <a:rPr sz="760" b="0" i="0">
-                <a:solidFill>
-                  <a:srgbClr val="0E1620"/>
-                </a:solidFill>
-                <a:latin typeface="Arial"/>
-              </a:rPr>
-              <a:t>1,492 campaigns, 2000–07</a:t>
-            </a:r>
-          </a:p>
-        </p:txBody>
-      </p:sp>
-      <p:sp>
-        <p:nvSpPr>
-          <p:cNvPr id="44" name="Rectangle 43"/>
-          <p:cNvSpPr/>
-          <p:nvPr/>
-        </p:nvSpPr>
-        <p:spPr>
-          <a:xfrm>
-            <a:off x="4754998" y="6037478"/>
-            <a:ext cx="4579429" cy="838809"/>
-          </a:xfrm>
-          <a:prstGeom prst="rect">
-            <a:avLst/>
-          </a:prstGeom>
-          <a:solidFill>
-            <a:srgbClr val="F6F7F9"/>
-          </a:solidFill>
-          <a:ln>
-            <a:noFill/>
-          </a:ln>
-          <a:effectLst/>
-        </p:spPr>
-        <p:style>
-          <a:lnRef idx="1">
-            <a:schemeClr val="accent1"/>
-          </a:lnRef>
-          <a:fillRef idx="3">
-            <a:schemeClr val="accent1"/>
-          </a:fillRef>
-          <a:effectRef idx="2">
-            <a:schemeClr val="accent1"/>
-          </a:effectRef>
-          <a:fontRef idx="minor">
-            <a:schemeClr val="lt1"/>
-          </a:fontRef>
-        </p:style>
-        <p:txBody>
-          <a:bodyPr rtlCol="0" anchor="ctr"/>
-          <a:lstStyle/>
-          <a:p>
-            <a:pPr algn="ctr"/>
-            <a:endParaRPr/>
-          </a:p>
-        </p:txBody>
-      </p:sp>
-      <p:sp>
-        <p:nvSpPr>
-          <p:cNvPr id="45" name="TextBox 44"/>
-          <p:cNvSpPr txBox="1"/>
-          <p:nvPr/>
-        </p:nvSpPr>
-        <p:spPr>
-          <a:xfrm>
-            <a:off x="4850098" y="6037478"/>
-            <a:ext cx="4403860" cy="838809"/>
-          </a:xfrm>
-          <a:prstGeom prst="rect">
-            <a:avLst/>
-          </a:prstGeom>
-          <a:noFill/>
-        </p:spPr>
-        <p:txBody>
-          <a:bodyPr wrap="square" lIns="0" tIns="0" rIns="0" bIns="0" anchor="ctr">
-            <a:spAutoFit/>
-          </a:bodyPr>
-          <a:lstStyle/>
-          <a:p>
-            <a:pPr algn="l">
-              <a:lnSpc>
-                <a:spcPct val="108000"/>
-              </a:lnSpc>
-              <a:spcAft>
-                <a:spcPts val="0"/>
-              </a:spcAft>
-            </a:pPr>
-            <a:r>
-              <a:rPr sz="760" b="0" i="0">
-                <a:solidFill>
-                  <a:srgbClr val="0E1620"/>
-                </a:solidFill>
-                <a:latin typeface="Arial"/>
-              </a:rPr>
-              <a:t>A campaign escalating to a proxy fight costs ~$10.7m; settling at the board-representation stage avoids most of it — collaboration is cheaper.</a:t>
-            </a:r>
-          </a:p>
-        </p:txBody>
-      </p:sp>
-      <p:sp>
-        <p:nvSpPr>
-          <p:cNvPr id="46" name="TextBox 45"/>
-          <p:cNvSpPr txBox="1"/>
-          <p:nvPr/>
-        </p:nvSpPr>
-        <p:spPr>
-          <a:xfrm>
-            <a:off x="438922" y="6993331"/>
-            <a:ext cx="8851613" cy="487680"/>
-          </a:xfrm>
-          <a:prstGeom prst="rect">
-            <a:avLst/>
-          </a:prstGeom>
-          <a:noFill/>
-        </p:spPr>
-        <p:txBody>
-          <a:bodyPr wrap="square" lIns="0" tIns="0" rIns="0" bIns="0" anchor="t">
-            <a:spAutoFit/>
-          </a:bodyPr>
-          <a:lstStyle/>
-          <a:p>
-            <a:pPr algn="l">
-              <a:lnSpc>
-                <a:spcPct val="110000"/>
-              </a:lnSpc>
-              <a:spcAft>
-                <a:spcPts val="0"/>
-              </a:spcAft>
-            </a:pPr>
-            <a:r>
-              <a:rPr sz="1000" b="0" i="1">
-                <a:solidFill>
-                  <a:srgbClr val="314359"/>
-                </a:solidFill>
-                <a:latin typeface="Arial"/>
-              </a:rPr>
-              <a:t>The academic record converges with our own 38 engagements: control secured cooperatively through a board seat is how operational value is created.</a:t>
+                  <a:srgbClr val="556A83"/>
+                </a:solidFill>
+                <a:latin typeface="Arial"/>
+              </a:rPr>
+              <a:t>And the opportunity set is deep and global: ~50,000 listed companies worldwide (World Federation of Exchanges, 2024); the investable MSCI ACWI IMI spans ~8,800 large-, mid- and small-cap names across 23 developed and 24 emerging markets — about 1,600 of them mid-caps (MSCI, 2024). Our €50m–€3bn target band, in markets with a stable legal system, is a large subset.</a:t>
             </a:r>
           </a:p>
         </p:txBody>

</xml_diff>

<commit_message>
Rebuild Figure 2 as an A+B=0 operating-result tree
Replaced the sum-of-the-parts bar chart (100 -> 140, +40%) with the more
intuitive A+B=0 tree the team prefers:
- Company X (central overhead -10) splits into a high-ROIIC Core (+30,
  strong prospects) and management's value-destroying pivot (-20, weak
  prospects), netting to ~0 reported operating result -> priced as broken
- Solid navy = the valuable core; hollow/light = the weak pivot
- Retitled the figure caption and rewrote the footnote (dropped +40%)
- Left-column narrative already told this story, so left unchanged

Also removed a dangling slide relationship (rId25) left over from the
earlier slide deletion, which caused a duplicate slide part on save.

https://claude.ai/code/session_01HRMxSvt6t94q3GFGUqavQe
</commit_message>
<xml_diff>
--- a/Athanase_Endowment_Pitch_21pp.pptx
+++ b/Athanase_Endowment_Pitch_21pp.pptx
@@ -942,335 +942,6 @@
 </c:chartSpace>
 </file>
 
-<file path=ppt/charts/chart3.xml><?xml version="1.0" encoding="utf-8"?>
-<c:chartSpace xmlns:c="http://schemas.openxmlformats.org/drawingml/2006/chart" xmlns:a="http://schemas.openxmlformats.org/drawingml/2006/main" xmlns:r="http://schemas.openxmlformats.org/officeDocument/2006/relationships" xmlns:c16r2="http://schemas.microsoft.com/office/drawing/2015/06/chart">
-  <c:date1904 val="0"/>
-  <c:lang val="en-US"/>
-  <c:roundedCorners val="1"/>
-  <c:style val="2"/>
-  <c:chart>
-    <c:title>
-      <c:tx>
-        <c:rich>
-          <a:bodyPr/>
-          <a:lstStyle/>
-          <a:p>
-            <a:r>
-              <a:t>Figure 5.  Growth of capital since 2006 (×)</a:t>
-            </a:r>
-          </a:p>
-        </c:rich>
-      </c:tx>
-      <c:overlay val="0"/>
-    </c:title>
-    <c:autoTitleDeleted val="0"/>
-    <c:plotArea>
-      <c:layout/>
-      <c:barChart>
-        <c:barDir val="col"/>
-        <c:grouping val="clustered"/>
-        <c:varyColors val="1"/>
-        <c:ser>
-          <c:idx val="0"/>
-          <c:order val="0"/>
-          <c:tx>
-            <c:strRef>
-              <c:f>Sheet1!$B$1</c:f>
-              <c:strCache>
-                <c:ptCount val="1"/>
-                <c:pt idx="0">
-                  <c:v>Athanase</c:v>
-                </c:pt>
-              </c:strCache>
-            </c:strRef>
-          </c:tx>
-          <c:spPr>
-            <a:solidFill>
-              <a:srgbClr val="152130"/>
-            </a:solidFill>
-          </c:spPr>
-          <c:invertIfNegative val="1"/>
-          <c:dLbls>
-            <c:numFmt formatCode="0.0&quot;%&quot;" sourceLinked="0"/>
-            <c:spPr>
-              <a:noFill/>
-              <a:ln>
-                <a:noFill/>
-              </a:ln>
-              <a:effectLst/>
-            </c:spPr>
-            <c:txPr>
-              <a:bodyPr/>
-              <a:lstStyle/>
-              <a:p>
-                <a:pPr>
-                  <a:defRPr sz="720">
-                    <a:solidFill>
-                      <a:srgbClr val="0E1620"/>
-                    </a:solidFill>
-                  </a:defRPr>
-                </a:pPr>
-                <a:endParaRPr lang="sv-SE"/>
-              </a:p>
-            </c:txPr>
-            <c:dLblPos val="outEnd"/>
-            <c:showLegendKey val="0"/>
-            <c:showVal val="1"/>
-            <c:showCatName val="0"/>
-            <c:showSerName val="0"/>
-            <c:showPercent val="0"/>
-            <c:showBubbleSize val="0"/>
-            <c:showLeaderLines val="0"/>
-            <c:extLst>
-              <c:ext xmlns:c15="http://schemas.microsoft.com/office/drawing/2012/chart" uri="{CE6537A1-D6FC-4f65-9D91-7224C49458BB}">
-                <c15:showLeaderLines val="0"/>
-              </c:ext>
-            </c:extLst>
-          </c:dLbls>
-          <c:cat>
-            <c:strRef>
-              <c:f>Sheet1!$A$2:$A$2</c:f>
-              <c:strCache>
-                <c:ptCount val="1"/>
-                <c:pt idx="0">
-                  <c:v>Since 2006</c:v>
-                </c:pt>
-              </c:strCache>
-            </c:strRef>
-          </c:cat>
-          <c:val>
-            <c:numRef>
-              <c:f>Sheet1!$B$2:$B$2</c:f>
-              <c:numCache>
-                <c:formatCode>General</c:formatCode>
-                <c:ptCount val="1"/>
-                <c:pt idx="0">
-                  <c:v>18.0</c:v>
-                </c:pt>
-              </c:numCache>
-            </c:numRef>
-          </c:val>
-          <c:extLst>
-            <c:ext xmlns:c14="http://schemas.microsoft.com/office/drawing/2007/8/2/chart" uri="{6F2FDCE9-48DA-4B69-8628-5D25D57E5C99}">
-              <c14:invertSolidFillFmt>
-                <c14:spPr xmlns:c14="http://schemas.microsoft.com/office/drawing/2007/8/2/chart">
-                  <a:solidFill>
-                    <a:srgbClr val="FFFFFF"/>
-                  </a:solidFill>
-                </c14:spPr>
-              </c14:invertSolidFillFmt>
-            </c:ext>
-            <c:ext xmlns:c16="http://schemas.microsoft.com/office/drawing/2014/chart" uri="{C3380CC4-5D6E-409C-BE32-E72D297353CC}">
-              <c16:uniqueId val="{00000000-E970-45BA-8499-251F9C2C08E0}"/>
-            </c:ext>
-          </c:extLst>
-        </c:ser>
-        <c:ser>
-          <c:idx val="1"/>
-          <c:order val="1"/>
-          <c:tx>
-            <c:strRef>
-              <c:f>Sheet1!$C$1</c:f>
-              <c:strCache>
-                <c:ptCount val="1"/>
-                <c:pt idx="0">
-                  <c:v>MSCI IMI</c:v>
-                </c:pt>
-              </c:strCache>
-            </c:strRef>
-          </c:tx>
-          <c:spPr>
-            <a:solidFill>
-              <a:srgbClr val="556A83"/>
-            </a:solidFill>
-          </c:spPr>
-          <c:invertIfNegative val="1"/>
-          <c:dLbls>
-            <c:numFmt formatCode="0.0&quot;%&quot;" sourceLinked="0"/>
-            <c:spPr>
-              <a:noFill/>
-              <a:ln>
-                <a:noFill/>
-              </a:ln>
-              <a:effectLst/>
-            </c:spPr>
-            <c:txPr>
-              <a:bodyPr/>
-              <a:lstStyle/>
-              <a:p>
-                <a:pPr>
-                  <a:defRPr sz="720">
-                    <a:solidFill>
-                      <a:srgbClr val="0E1620"/>
-                    </a:solidFill>
-                  </a:defRPr>
-                </a:pPr>
-                <a:endParaRPr lang="sv-SE"/>
-              </a:p>
-            </c:txPr>
-            <c:dLblPos val="outEnd"/>
-            <c:showLegendKey val="0"/>
-            <c:showVal val="1"/>
-            <c:showCatName val="0"/>
-            <c:showSerName val="0"/>
-            <c:showPercent val="0"/>
-            <c:showBubbleSize val="0"/>
-            <c:showLeaderLines val="0"/>
-            <c:extLst>
-              <c:ext xmlns:c15="http://schemas.microsoft.com/office/drawing/2012/chart" uri="{CE6537A1-D6FC-4f65-9D91-7224C49458BB}">
-                <c15:showLeaderLines val="0"/>
-              </c:ext>
-            </c:extLst>
-          </c:dLbls>
-          <c:cat>
-            <c:strRef>
-              <c:f>Sheet1!$A$2:$A$2</c:f>
-              <c:strCache>
-                <c:ptCount val="1"/>
-                <c:pt idx="0">
-                  <c:v>Since 2006</c:v>
-                </c:pt>
-              </c:strCache>
-            </c:strRef>
-          </c:cat>
-          <c:val>
-            <c:numRef>
-              <c:f>Sheet1!$C$2:$C$2</c:f>
-              <c:numCache>
-                <c:formatCode>General</c:formatCode>
-                <c:ptCount val="1"/>
-                <c:pt idx="0">
-                  <c:v>3.2</c:v>
-                </c:pt>
-              </c:numCache>
-            </c:numRef>
-          </c:val>
-          <c:extLst>
-            <c:ext xmlns:c14="http://schemas.microsoft.com/office/drawing/2007/8/2/chart" uri="{6F2FDCE9-48DA-4B69-8628-5D25D57E5C99}">
-              <c14:invertSolidFillFmt>
-                <c14:spPr xmlns:c14="http://schemas.microsoft.com/office/drawing/2007/8/2/chart">
-                  <a:solidFill>
-                    <a:srgbClr val="FFFFFF"/>
-                  </a:solidFill>
-                </c14:spPr>
-              </c14:invertSolidFillFmt>
-            </c:ext>
-            <c:ext xmlns:c16="http://schemas.microsoft.com/office/drawing/2014/chart" uri="{C3380CC4-5D6E-409C-BE32-E72D297353CC}">
-              <c16:uniqueId val="{00000001-E970-45BA-8499-251F9C2C08E0}"/>
-            </c:ext>
-          </c:extLst>
-        </c:ser>
-        <c:dLbls>
-          <c:numFmt formatCode="0.0&quot;×&quot;" sourceLinked="0"/>
-          <c:dLblPos val="outEnd"/>
-          <c:showLegendKey val="0"/>
-          <c:showVal val="1"/>
-          <c:showCatName val="0"/>
-          <c:showSerName val="0"/>
-          <c:showPercent val="0"/>
-          <c:showBubbleSize val="0"/>
-        </c:dLbls>
-        <c:gapWidth val="80"/>
-        <c:axId val="-2068027336"/>
-        <c:axId val="-2113994440"/>
-      </c:barChart>
-      <c:catAx>
-        <c:axId val="-2068027336"/>
-        <c:scaling>
-          <c:orientation val="minMax"/>
-        </c:scaling>
-        <c:delete val="0"/>
-        <c:axPos val="b"/>
-        <c:numFmt formatCode="General" sourceLinked="0"/>
-        <c:majorTickMark val="out"/>
-        <c:minorTickMark val="none"/>
-        <c:tickLblPos val="nextTo"/>
-        <c:txPr>
-          <a:bodyPr/>
-          <a:lstStyle/>
-          <a:p>
-            <a:pPr>
-              <a:defRPr sz="800">
-                <a:solidFill>
-                  <a:srgbClr val="0E1620"/>
-                </a:solidFill>
-              </a:defRPr>
-            </a:pPr>
-            <a:endParaRPr lang="sv-SE"/>
-          </a:p>
-        </c:txPr>
-        <c:crossAx val="-2113994440"/>
-        <c:crosses val="autoZero"/>
-        <c:auto val="1"/>
-        <c:lblAlgn val="ctr"/>
-        <c:lblOffset val="100"/>
-        <c:noMultiLvlLbl val="0"/>
-      </c:catAx>
-      <c:valAx>
-        <c:axId val="-2113994440"/>
-        <c:scaling>
-          <c:orientation val="minMax"/>
-        </c:scaling>
-        <c:delete val="0"/>
-        <c:axPos val="l"/>
-        <c:majorGridlines/>
-        <c:numFmt formatCode="General" sourceLinked="1"/>
-        <c:majorTickMark val="out"/>
-        <c:minorTickMark val="none"/>
-        <c:tickLblPos val="nextTo"/>
-        <c:txPr>
-          <a:bodyPr/>
-          <a:lstStyle/>
-          <a:p>
-            <a:pPr>
-              <a:defRPr sz="800">
-                <a:solidFill>
-                  <a:srgbClr val="0E1620"/>
-                </a:solidFill>
-              </a:defRPr>
-            </a:pPr>
-            <a:endParaRPr lang="sv-SE"/>
-          </a:p>
-        </c:txPr>
-        <c:crossAx val="-2068027336"/>
-        <c:crosses val="autoZero"/>
-        <c:crossBetween val="between"/>
-      </c:valAx>
-    </c:plotArea>
-    <c:legend>
-      <c:legendPos val="b"/>
-      <c:overlay val="0"/>
-      <c:txPr>
-        <a:bodyPr/>
-        <a:lstStyle/>
-        <a:p>
-          <a:pPr>
-            <a:defRPr sz="880"/>
-          </a:pPr>
-          <a:endParaRPr lang="sv-SE"/>
-        </a:p>
-      </c:txPr>
-    </c:legend>
-    <c:plotVisOnly val="1"/>
-    <c:dispBlanksAs val="gap"/>
-    <c:showDLblsOverMax val="1"/>
-  </c:chart>
-  <c:txPr>
-    <a:bodyPr/>
-    <a:lstStyle/>
-    <a:p>
-      <a:pPr>
-        <a:defRPr sz="1440"/>
-      </a:pPr>
-      <a:endParaRPr lang="en-US"/>
-    </a:p>
-  </c:txPr>
-  <c:externalData r:id="rId1">
-    <c:autoUpdate val="0"/>
-  </c:externalData>
-</c:chartSpace>
-</file>
-
 <file path=ppt/notesMasters/notesMaster1.xml><?xml version="1.0" encoding="utf-8"?>
 <p:notesMaster xmlns:a="http://schemas.openxmlformats.org/drawingml/2006/main" xmlns:r="http://schemas.openxmlformats.org/officeDocument/2006/relationships" xmlns:p="http://schemas.openxmlformats.org/presentationml/2006/main">
   <p:cSld>
@@ -11250,24 +10921,244 @@
                 </a:solidFill>
                 <a:latin typeface="Arial"/>
               </a:rPr>
-              <a:t>Figure 2  ·  SUM-OF-THE-PARTS (ILLUSTRATIVE · CONSTANT MULTIPLE)</a:t>
-            </a:r>
-          </a:p>
-        </p:txBody>
-      </p:sp>
-      <p:sp>
-        <p:nvSpPr>
-          <p:cNvPr id="12" name="Rectangle 11"/>
+              <a:t>Figure 2  ·  WHY THE EARNINGS LOOK LIKE ZERO  (ILLUSTRATIVE)</a:t>
+            </a:r>
+          </a:p>
+        </p:txBody>
+      </p:sp>
+      <p:sp>
+        <p:nvSpPr>
+          <p:cNvPr id="21" name="TextBox 20"/>
+          <p:cNvSpPr txBox="1"/>
+          <p:nvPr/>
+        </p:nvSpPr>
+        <p:spPr>
+          <a:xfrm>
+            <a:off x="512076" y="6291072"/>
+            <a:ext cx="8778459" cy="487680"/>
+          </a:xfrm>
+          <a:prstGeom prst="rect">
+            <a:avLst/>
+          </a:prstGeom>
+          <a:noFill/>
+        </p:spPr>
+        <p:txBody>
+          <a:bodyPr wrap="square" lIns="0" tIns="0" rIns="0" bIns="0" anchor="t">
+            <a:spAutoFit/>
+          </a:bodyPr>
+          <a:lstStyle/>
+          <a:p>
+            <a:pPr algn="l">
+              <a:lnSpc>
+                <a:spcPct val="110000"/>
+              </a:lnSpc>
+              <a:spcAft>
+                <a:spcPts val="0"/>
+              </a:spcAft>
+            </a:pPr>
+            <a:r>
+              <a:rPr sz="1040" b="0" i="1">
+                <a:solidFill>
+                  <a:srgbClr val="314359"/>
+                </a:solidFill>
+                <a:latin typeface="Arial"/>
+              </a:rPr>
+              <a:t>Reported earnings near zero — so the market prices the whole company as broken. We buy it, fix or exit the pivot, and the core’s high-ROIIC earnings surface: value we underwrite at zero.</a:t>
+            </a:r>
+          </a:p>
+        </p:txBody>
+      </p:sp>
+      <p:sp>
+        <p:nvSpPr>
+          <p:cNvPr id="22" name="Rectangle 21"/>
           <p:cNvSpPr/>
           <p:nvPr/>
         </p:nvSpPr>
         <p:spPr>
           <a:xfrm>
-            <a:off x="5852306" y="3706368"/>
-            <a:ext cx="1170461" cy="1658112"/>
-          </a:xfrm>
-          <a:prstGeom prst="rect">
-            <a:avLst/>
+            <a:off x="7307884" y="3218688"/>
+            <a:ext cx="14630" cy="237744"/>
+          </a:xfrm>
+          <a:prstGeom prst="rect">
+            <a:avLst/>
+          </a:prstGeom>
+          <a:solidFill>
+            <a:srgbClr val="556A83"/>
+          </a:solidFill>
+          <a:ln>
+            <a:noFill/>
+          </a:ln>
+          <a:effectLst/>
+        </p:spPr>
+        <p:style>
+          <a:lnRef idx="1">
+            <a:schemeClr val="accent1"/>
+          </a:lnRef>
+          <a:fillRef idx="3">
+            <a:schemeClr val="accent1"/>
+          </a:fillRef>
+          <a:effectRef idx="2">
+            <a:schemeClr val="accent1"/>
+          </a:effectRef>
+          <a:fontRef idx="minor">
+            <a:schemeClr val="lt1"/>
+          </a:fontRef>
+        </p:style>
+        <p:txBody>
+          <a:bodyPr rtlCol="0" anchor="ctr"/>
+          <a:lstStyle/>
+          <a:p>
+            <a:pPr algn="ctr"/>
+          </a:p>
+        </p:txBody>
+      </p:sp>
+      <p:sp>
+        <p:nvSpPr>
+          <p:cNvPr id="23" name="Rectangle 22"/>
+          <p:cNvSpPr/>
+          <p:nvPr/>
+        </p:nvSpPr>
+        <p:spPr>
+          <a:xfrm>
+            <a:off x="6277356" y="3456432"/>
+            <a:ext cx="2075688" cy="14630"/>
+          </a:xfrm>
+          <a:prstGeom prst="rect">
+            <a:avLst/>
+          </a:prstGeom>
+          <a:solidFill>
+            <a:srgbClr val="556A83"/>
+          </a:solidFill>
+          <a:ln>
+            <a:noFill/>
+          </a:ln>
+          <a:effectLst/>
+        </p:spPr>
+        <p:style>
+          <a:lnRef idx="1">
+            <a:schemeClr val="accent1"/>
+          </a:lnRef>
+          <a:fillRef idx="3">
+            <a:schemeClr val="accent1"/>
+          </a:fillRef>
+          <a:effectRef idx="2">
+            <a:schemeClr val="accent1"/>
+          </a:effectRef>
+          <a:fontRef idx="minor">
+            <a:schemeClr val="lt1"/>
+          </a:fontRef>
+        </p:style>
+        <p:txBody>
+          <a:bodyPr rtlCol="0" anchor="ctr"/>
+          <a:lstStyle/>
+          <a:p>
+            <a:pPr algn="ctr"/>
+          </a:p>
+        </p:txBody>
+      </p:sp>
+      <p:sp>
+        <p:nvSpPr>
+          <p:cNvPr id="24" name="Rectangle 23"/>
+          <p:cNvSpPr/>
+          <p:nvPr/>
+        </p:nvSpPr>
+        <p:spPr>
+          <a:xfrm>
+            <a:off x="6270040" y="3456432"/>
+            <a:ext cx="14630" cy="182880"/>
+          </a:xfrm>
+          <a:prstGeom prst="rect">
+            <a:avLst/>
+          </a:prstGeom>
+          <a:solidFill>
+            <a:srgbClr val="556A83"/>
+          </a:solidFill>
+          <a:ln>
+            <a:noFill/>
+          </a:ln>
+          <a:effectLst/>
+        </p:spPr>
+        <p:style>
+          <a:lnRef idx="1">
+            <a:schemeClr val="accent1"/>
+          </a:lnRef>
+          <a:fillRef idx="3">
+            <a:schemeClr val="accent1"/>
+          </a:fillRef>
+          <a:effectRef idx="2">
+            <a:schemeClr val="accent1"/>
+          </a:effectRef>
+          <a:fontRef idx="minor">
+            <a:schemeClr val="lt1"/>
+          </a:fontRef>
+        </p:style>
+        <p:txBody>
+          <a:bodyPr rtlCol="0" anchor="ctr"/>
+          <a:lstStyle/>
+          <a:p>
+            <a:pPr algn="ctr"/>
+          </a:p>
+        </p:txBody>
+      </p:sp>
+      <p:sp>
+        <p:nvSpPr>
+          <p:cNvPr id="25" name="Rectangle 24"/>
+          <p:cNvSpPr/>
+          <p:nvPr/>
+        </p:nvSpPr>
+        <p:spPr>
+          <a:xfrm>
+            <a:off x="8345728" y="3456432"/>
+            <a:ext cx="14630" cy="182880"/>
+          </a:xfrm>
+          <a:prstGeom prst="rect">
+            <a:avLst/>
+          </a:prstGeom>
+          <a:solidFill>
+            <a:srgbClr val="556A83"/>
+          </a:solidFill>
+          <a:ln>
+            <a:noFill/>
+          </a:ln>
+          <a:effectLst/>
+        </p:spPr>
+        <p:style>
+          <a:lnRef idx="1">
+            <a:schemeClr val="accent1"/>
+          </a:lnRef>
+          <a:fillRef idx="3">
+            <a:schemeClr val="accent1"/>
+          </a:fillRef>
+          <a:effectRef idx="2">
+            <a:schemeClr val="accent1"/>
+          </a:effectRef>
+          <a:fontRef idx="minor">
+            <a:schemeClr val="lt1"/>
+          </a:fontRef>
+        </p:style>
+        <p:txBody>
+          <a:bodyPr rtlCol="0" anchor="ctr"/>
+          <a:lstStyle/>
+          <a:p>
+            <a:pPr algn="ctr"/>
+          </a:p>
+        </p:txBody>
+      </p:sp>
+      <p:sp>
+        <p:nvSpPr>
+          <p:cNvPr id="26" name="Rounded Rectangle 25"/>
+          <p:cNvSpPr/>
+          <p:nvPr/>
+        </p:nvSpPr>
+        <p:spPr>
+          <a:xfrm>
+            <a:off x="6263640" y="2670048"/>
+            <a:ext cx="2103120" cy="548640"/>
+          </a:xfrm>
+          <a:prstGeom prst="roundRect">
+            <a:avLst>
+              <a:gd name="adj" fmla="val 10000"/>
+            </a:avLst>
           </a:prstGeom>
           <a:solidFill>
             <a:srgbClr val="314359"/>
@@ -11292,323 +11183,49 @@
           </a:fontRef>
         </p:style>
         <p:txBody>
-          <a:bodyPr rtlCol="0" anchor="ctr"/>
+          <a:bodyPr rtlCol="0" anchor="ctr" wrap="square" lIns="54864" rIns="54864" tIns="18288" bIns="18288"/>
           <a:lstStyle/>
           <a:p>
             <a:pPr algn="ctr"/>
-            <a:endParaRPr/>
-          </a:p>
-        </p:txBody>
-      </p:sp>
-      <p:sp>
-        <p:nvSpPr>
-          <p:cNvPr id="13" name="TextBox 12"/>
-          <p:cNvSpPr txBox="1"/>
-          <p:nvPr/>
-        </p:nvSpPr>
-        <p:spPr>
-          <a:xfrm>
-            <a:off x="5852306" y="3355238"/>
-            <a:ext cx="1170461" cy="312115"/>
-          </a:xfrm>
-          <a:prstGeom prst="rect">
-            <a:avLst/>
-          </a:prstGeom>
-          <a:noFill/>
-        </p:spPr>
-        <p:txBody>
-          <a:bodyPr wrap="square" lIns="0" tIns="0" rIns="0" bIns="0" anchor="t">
-            <a:spAutoFit/>
-          </a:bodyPr>
-          <a:lstStyle/>
-          <a:p>
-            <a:pPr algn="ctr">
-              <a:lnSpc>
-                <a:spcPct val="110000"/>
-              </a:lnSpc>
-              <a:spcAft>
-                <a:spcPts val="0"/>
-              </a:spcAft>
-            </a:pPr>
-            <a:r>
-              <a:rPr sz="1120" b="1" i="0">
-                <a:solidFill>
-                  <a:srgbClr val="314359"/>
-                </a:solidFill>
-                <a:latin typeface="Arial"/>
-              </a:rPr>
-              <a:t>100</a:t>
-            </a:r>
-          </a:p>
-        </p:txBody>
-      </p:sp>
-      <p:sp>
-        <p:nvSpPr>
-          <p:cNvPr id="14" name="TextBox 13"/>
-          <p:cNvSpPr txBox="1"/>
-          <p:nvPr/>
-        </p:nvSpPr>
-        <p:spPr>
-          <a:xfrm>
-            <a:off x="5559691" y="5462016"/>
-            <a:ext cx="1755691" cy="585216"/>
-          </a:xfrm>
-          <a:prstGeom prst="rect">
-            <a:avLst/>
-          </a:prstGeom>
-          <a:noFill/>
-        </p:spPr>
-        <p:txBody>
-          <a:bodyPr wrap="square" lIns="0" tIns="0" rIns="0" bIns="0" anchor="t">
-            <a:spAutoFit/>
-          </a:bodyPr>
-          <a:lstStyle/>
-          <a:p>
-            <a:pPr algn="ctr">
-              <a:lnSpc>
-                <a:spcPct val="100000"/>
-              </a:lnSpc>
-              <a:spcAft>
-                <a:spcPts val="0"/>
-              </a:spcAft>
-            </a:pPr>
-            <a:r>
-              <a:rPr sz="919" b="1" i="0">
-                <a:solidFill>
-                  <a:srgbClr val="0E1620"/>
-                </a:solidFill>
-                <a:latin typeface="Arial"/>
-              </a:rPr>
-              <a:t>Market price</a:t>
-            </a:r>
-          </a:p>
-          <a:p>
-            <a:pPr algn="ctr">
-              <a:lnSpc>
-                <a:spcPct val="100000"/>
-              </a:lnSpc>
-              <a:spcAft>
-                <a:spcPts val="0"/>
-              </a:spcAft>
-            </a:pPr>
-            <a:r>
-              <a:rPr sz="800" b="0" i="0">
-                <a:solidFill>
-                  <a:srgbClr val="0E1620"/>
-                </a:solidFill>
-                <a:latin typeface="Arial"/>
-              </a:rPr>
-              <a:t>(blended optics)</a:t>
-            </a:r>
-          </a:p>
-        </p:txBody>
-      </p:sp>
-      <p:sp>
-        <p:nvSpPr>
-          <p:cNvPr id="15" name="Rectangle 14"/>
+            <a:r>
+              <a:rPr sz="1100" b="1">
+                <a:solidFill>
+                  <a:srgbClr val="FFFFFF"/>
+                </a:solidFill>
+                <a:latin typeface="Arial"/>
+              </a:rPr>
+              <a:t>Company X</a:t>
+            </a:r>
+          </a:p>
+          <a:p>
+            <a:pPr algn="ctr"/>
+            <a:r>
+              <a:rPr sz="850" b="0">
+                <a:solidFill>
+                  <a:srgbClr val="C9D2DD"/>
+                </a:solidFill>
+                <a:latin typeface="Arial"/>
+              </a:rPr>
+              <a:t>central overhead  −10</a:t>
+            </a:r>
+          </a:p>
+        </p:txBody>
+      </p:sp>
+      <p:sp>
+        <p:nvSpPr>
+          <p:cNvPr id="27" name="Rounded Rectangle 26"/>
           <p:cNvSpPr/>
           <p:nvPr/>
         </p:nvSpPr>
         <p:spPr>
           <a:xfrm>
-            <a:off x="7754305" y="3043123"/>
-            <a:ext cx="1170461" cy="2321356"/>
-          </a:xfrm>
-          <a:prstGeom prst="rect">
-            <a:avLst/>
-          </a:prstGeom>
-          <a:solidFill>
-            <a:srgbClr val="152130"/>
-          </a:solidFill>
-          <a:ln>
-            <a:noFill/>
-          </a:ln>
-          <a:effectLst/>
-        </p:spPr>
-        <p:style>
-          <a:lnRef idx="1">
-            <a:schemeClr val="accent1"/>
-          </a:lnRef>
-          <a:fillRef idx="3">
-            <a:schemeClr val="accent1"/>
-          </a:fillRef>
-          <a:effectRef idx="2">
-            <a:schemeClr val="accent1"/>
-          </a:effectRef>
-          <a:fontRef idx="minor">
-            <a:schemeClr val="lt1"/>
-          </a:fontRef>
-        </p:style>
-        <p:txBody>
-          <a:bodyPr rtlCol="0" anchor="ctr"/>
-          <a:lstStyle/>
-          <a:p>
-            <a:pPr algn="ctr"/>
-            <a:endParaRPr/>
-          </a:p>
-        </p:txBody>
-      </p:sp>
-      <p:sp>
-        <p:nvSpPr>
-          <p:cNvPr id="16" name="TextBox 15"/>
-          <p:cNvSpPr txBox="1"/>
-          <p:nvPr/>
-        </p:nvSpPr>
-        <p:spPr>
-          <a:xfrm>
-            <a:off x="7754305" y="2691993"/>
-            <a:ext cx="1170461" cy="312115"/>
-          </a:xfrm>
-          <a:prstGeom prst="rect">
-            <a:avLst/>
-          </a:prstGeom>
-          <a:noFill/>
-        </p:spPr>
-        <p:txBody>
-          <a:bodyPr wrap="square" lIns="0" tIns="0" rIns="0" bIns="0" anchor="t">
-            <a:spAutoFit/>
-          </a:bodyPr>
-          <a:lstStyle/>
-          <a:p>
-            <a:pPr algn="ctr">
-              <a:lnSpc>
-                <a:spcPct val="110000"/>
-              </a:lnSpc>
-              <a:spcAft>
-                <a:spcPts val="0"/>
-              </a:spcAft>
-            </a:pPr>
-            <a:r>
-              <a:rPr sz="1120" b="1" i="0">
-                <a:solidFill>
-                  <a:srgbClr val="314359"/>
-                </a:solidFill>
-                <a:latin typeface="Arial"/>
-              </a:rPr>
-              <a:t>140</a:t>
-            </a:r>
-          </a:p>
-        </p:txBody>
-      </p:sp>
-      <p:sp>
-        <p:nvSpPr>
-          <p:cNvPr id="17" name="TextBox 16"/>
-          <p:cNvSpPr txBox="1"/>
-          <p:nvPr/>
-        </p:nvSpPr>
-        <p:spPr>
-          <a:xfrm>
-            <a:off x="7461690" y="5462016"/>
-            <a:ext cx="1755691" cy="585216"/>
-          </a:xfrm>
-          <a:prstGeom prst="rect">
-            <a:avLst/>
-          </a:prstGeom>
-          <a:noFill/>
-        </p:spPr>
-        <p:txBody>
-          <a:bodyPr wrap="square" lIns="0" tIns="0" rIns="0" bIns="0" anchor="t">
-            <a:spAutoFit/>
-          </a:bodyPr>
-          <a:lstStyle/>
-          <a:p>
-            <a:pPr algn="ctr">
-              <a:lnSpc>
-                <a:spcPct val="100000"/>
-              </a:lnSpc>
-              <a:spcAft>
-                <a:spcPts val="0"/>
-              </a:spcAft>
-            </a:pPr>
-            <a:r>
-              <a:rPr sz="919" b="1" i="0">
-                <a:solidFill>
-                  <a:srgbClr val="0E1620"/>
-                </a:solidFill>
-                <a:latin typeface="Arial"/>
-              </a:rPr>
-              <a:t>Core alone</a:t>
-            </a:r>
-          </a:p>
-          <a:p>
-            <a:pPr algn="ctr">
-              <a:lnSpc>
-                <a:spcPct val="100000"/>
-              </a:lnSpc>
-              <a:spcAft>
-                <a:spcPts val="0"/>
-              </a:spcAft>
-            </a:pPr>
-            <a:r>
-              <a:rPr sz="800" b="0" i="0">
-                <a:solidFill>
-                  <a:srgbClr val="0E1620"/>
-                </a:solidFill>
-                <a:latin typeface="Arial"/>
-              </a:rPr>
-              <a:t>(high ROIIC)</a:t>
-            </a:r>
-          </a:p>
-        </p:txBody>
-      </p:sp>
-      <p:sp>
-        <p:nvSpPr>
-          <p:cNvPr id="18" name="Rectangle 17"/>
-          <p:cNvSpPr/>
-          <p:nvPr/>
-        </p:nvSpPr>
-        <p:spPr>
-          <a:xfrm>
-            <a:off x="5852306" y="3706368"/>
-            <a:ext cx="2487230" cy="16256"/>
-          </a:xfrm>
-          <a:prstGeom prst="rect">
-            <a:avLst/>
-          </a:prstGeom>
-          <a:solidFill>
-            <a:srgbClr val="556A83"/>
-          </a:solidFill>
-          <a:ln>
-            <a:noFill/>
-          </a:ln>
-          <a:effectLst/>
-        </p:spPr>
-        <p:style>
-          <a:lnRef idx="1">
-            <a:schemeClr val="accent1"/>
-          </a:lnRef>
-          <a:fillRef idx="3">
-            <a:schemeClr val="accent1"/>
-          </a:fillRef>
-          <a:effectRef idx="2">
-            <a:schemeClr val="accent1"/>
-          </a:effectRef>
-          <a:fontRef idx="minor">
-            <a:schemeClr val="lt1"/>
-          </a:fontRef>
-        </p:style>
-        <p:txBody>
-          <a:bodyPr rtlCol="0" anchor="ctr"/>
-          <a:lstStyle/>
-          <a:p>
-            <a:pPr algn="ctr"/>
-            <a:endParaRPr/>
-          </a:p>
-        </p:txBody>
-      </p:sp>
-      <p:sp>
-        <p:nvSpPr>
-          <p:cNvPr id="19" name="Rectangle 18"/>
-          <p:cNvSpPr/>
-          <p:nvPr/>
-        </p:nvSpPr>
-        <p:spPr>
-          <a:xfrm>
-            <a:off x="8741882" y="3043123"/>
-            <a:ext cx="20320" cy="663244"/>
-          </a:xfrm>
-          <a:prstGeom prst="rect">
-            <a:avLst/>
+            <a:off x="5340096" y="3639312"/>
+            <a:ext cx="1874519" cy="731520"/>
+          </a:xfrm>
+          <a:prstGeom prst="roundRect">
+            <a:avLst>
+              <a:gd name="adj" fmla="val 10000"/>
+            </a:avLst>
           </a:prstGeom>
           <a:solidFill>
             <a:srgbClr val="314359"/>
@@ -11633,94 +11250,217 @@
           </a:fontRef>
         </p:style>
         <p:txBody>
+          <a:bodyPr rtlCol="0" anchor="ctr" wrap="square" lIns="54864" rIns="54864" tIns="18288" bIns="18288"/>
+          <a:lstStyle/>
+          <a:p>
+            <a:pPr algn="ctr"/>
+            <a:r>
+              <a:rPr sz="1050" b="1">
+                <a:solidFill>
+                  <a:srgbClr val="FFFFFF"/>
+                </a:solidFill>
+                <a:latin typeface="Arial"/>
+              </a:rPr>
+              <a:t>Core business    +30</a:t>
+            </a:r>
+          </a:p>
+          <a:p>
+            <a:pPr algn="ctr"/>
+            <a:r>
+              <a:rPr sz="830" b="0">
+                <a:solidFill>
+                  <a:srgbClr val="C9D2DD"/>
+                </a:solidFill>
+                <a:latin typeface="Arial"/>
+              </a:rPr>
+              <a:t>high ROIIC · strong prospects</a:t>
+            </a:r>
+          </a:p>
+        </p:txBody>
+      </p:sp>
+      <p:sp>
+        <p:nvSpPr>
+          <p:cNvPr id="28" name="Rounded Rectangle 27"/>
+          <p:cNvSpPr/>
+          <p:nvPr/>
+        </p:nvSpPr>
+        <p:spPr>
+          <a:xfrm>
+            <a:off x="7415783" y="3639312"/>
+            <a:ext cx="1874519" cy="731520"/>
+          </a:xfrm>
+          <a:prstGeom prst="roundRect">
+            <a:avLst>
+              <a:gd name="adj" fmla="val 10000"/>
+            </a:avLst>
+          </a:prstGeom>
+          <a:solidFill>
+            <a:srgbClr val="F6F7F9"/>
+          </a:solidFill>
+          <a:ln w="12700">
+            <a:solidFill>
+              <a:srgbClr val="556A83"/>
+            </a:solidFill>
+          </a:ln>
+          <a:effectLst/>
+        </p:spPr>
+        <p:style>
+          <a:lnRef idx="1">
+            <a:schemeClr val="accent1"/>
+          </a:lnRef>
+          <a:fillRef idx="3">
+            <a:schemeClr val="accent1"/>
+          </a:fillRef>
+          <a:effectRef idx="2">
+            <a:schemeClr val="accent1"/>
+          </a:effectRef>
+          <a:fontRef idx="minor">
+            <a:schemeClr val="lt1"/>
+          </a:fontRef>
+        </p:style>
+        <p:txBody>
+          <a:bodyPr rtlCol="0" anchor="ctr" wrap="square" lIns="54864" rIns="54864" tIns="18288" bIns="18288"/>
+          <a:lstStyle/>
+          <a:p>
+            <a:pPr algn="ctr"/>
+            <a:r>
+              <a:rPr sz="1050" b="1">
+                <a:solidFill>
+                  <a:srgbClr val="314359"/>
+                </a:solidFill>
+                <a:latin typeface="Arial"/>
+              </a:rPr>
+              <a:t>Mgmt’s pivot    −20</a:t>
+            </a:r>
+          </a:p>
+          <a:p>
+            <a:pPr algn="ctr"/>
+            <a:r>
+              <a:rPr sz="830" b="0">
+                <a:solidFill>
+                  <a:srgbClr val="556A83"/>
+                </a:solidFill>
+                <a:latin typeface="Arial"/>
+              </a:rPr>
+              <a:t>poor returns · weak prospects</a:t>
+            </a:r>
+          </a:p>
+        </p:txBody>
+      </p:sp>
+      <p:sp>
+        <p:nvSpPr>
+          <p:cNvPr id="29" name="Rectangle 28"/>
+          <p:cNvSpPr/>
+          <p:nvPr/>
+        </p:nvSpPr>
+        <p:spPr>
+          <a:xfrm>
+            <a:off x="6400800" y="4425696"/>
+            <a:ext cx="1828800" cy="274320"/>
+          </a:xfrm>
+          <a:prstGeom prst="rect">
+            <a:avLst/>
+          </a:prstGeom>
+          <a:noFill/>
+          <a:ln>
+            <a:noFill/>
+          </a:ln>
+          <a:effectLst/>
+        </p:spPr>
+        <p:style>
+          <a:lnRef idx="1">
+            <a:schemeClr val="accent1"/>
+          </a:lnRef>
+          <a:fillRef idx="3">
+            <a:schemeClr val="accent1"/>
+          </a:fillRef>
+          <a:effectRef idx="2">
+            <a:schemeClr val="accent1"/>
+          </a:effectRef>
+          <a:fontRef idx="minor">
+            <a:schemeClr val="lt1"/>
+          </a:fontRef>
+        </p:style>
+        <p:txBody>
           <a:bodyPr rtlCol="0" anchor="ctr"/>
           <a:lstStyle/>
           <a:p>
             <a:pPr algn="ctr"/>
-            <a:endParaRPr/>
-          </a:p>
-        </p:txBody>
-      </p:sp>
-      <p:sp>
-        <p:nvSpPr>
-          <p:cNvPr id="20" name="TextBox 19"/>
-          <p:cNvSpPr txBox="1"/>
-          <p:nvPr/>
-        </p:nvSpPr>
-        <p:spPr>
-          <a:xfrm>
-            <a:off x="5962037" y="3082137"/>
-            <a:ext cx="2633537" cy="487680"/>
-          </a:xfrm>
-          <a:prstGeom prst="rect">
-            <a:avLst/>
-          </a:prstGeom>
-          <a:noFill/>
-        </p:spPr>
-        <p:txBody>
-          <a:bodyPr wrap="square" lIns="0" tIns="0" rIns="0" bIns="0" anchor="t">
-            <a:spAutoFit/>
-          </a:bodyPr>
-          <a:lstStyle/>
-          <a:p>
-            <a:pPr algn="l">
-              <a:lnSpc>
-                <a:spcPct val="110000"/>
-              </a:lnSpc>
-              <a:spcAft>
-                <a:spcPts val="0"/>
-              </a:spcAft>
-            </a:pPr>
-            <a:r>
-              <a:rPr sz="960" b="1" i="0">
+            <a:r>
+              <a:rPr sz="1500" b="1">
+                <a:solidFill>
+                  <a:srgbClr val="556A83"/>
+                </a:solidFill>
+                <a:latin typeface="Arial"/>
+              </a:rPr>
+              <a:t>=</a:t>
+            </a:r>
+          </a:p>
+        </p:txBody>
+      </p:sp>
+      <p:sp>
+        <p:nvSpPr>
+          <p:cNvPr id="30" name="Rounded Rectangle 29"/>
+          <p:cNvSpPr/>
+          <p:nvPr/>
+        </p:nvSpPr>
+        <p:spPr>
+          <a:xfrm>
+            <a:off x="5760720" y="4718304"/>
+            <a:ext cx="3108960" cy="566928"/>
+          </a:xfrm>
+          <a:prstGeom prst="roundRect">
+            <a:avLst>
+              <a:gd name="adj" fmla="val 10000"/>
+            </a:avLst>
+          </a:prstGeom>
+          <a:solidFill>
+            <a:srgbClr val="F6F7F9"/>
+          </a:solidFill>
+          <a:ln>
+            <a:noFill/>
+          </a:ln>
+          <a:effectLst/>
+        </p:spPr>
+        <p:style>
+          <a:lnRef idx="1">
+            <a:schemeClr val="accent1"/>
+          </a:lnRef>
+          <a:fillRef idx="3">
+            <a:schemeClr val="accent1"/>
+          </a:fillRef>
+          <a:effectRef idx="2">
+            <a:schemeClr val="accent1"/>
+          </a:effectRef>
+          <a:fontRef idx="minor">
+            <a:schemeClr val="lt1"/>
+          </a:fontRef>
+        </p:style>
+        <p:txBody>
+          <a:bodyPr rtlCol="0" anchor="ctr" wrap="square" lIns="54864" rIns="54864" tIns="18288" bIns="18288"/>
+          <a:lstStyle/>
+          <a:p>
+            <a:pPr algn="ctr"/>
+            <a:r>
+              <a:rPr sz="1050" b="1">
                 <a:solidFill>
                   <a:srgbClr val="314359"/>
                 </a:solidFill>
                 <a:latin typeface="Arial"/>
               </a:rPr>
-              <a:t>+40% hidden value</a:t>
-            </a:r>
-          </a:p>
-        </p:txBody>
-      </p:sp>
-      <p:sp>
-        <p:nvSpPr>
-          <p:cNvPr id="21" name="TextBox 20"/>
-          <p:cNvSpPr txBox="1"/>
-          <p:nvPr/>
-        </p:nvSpPr>
-        <p:spPr>
-          <a:xfrm>
-            <a:off x="512076" y="6291072"/>
-            <a:ext cx="8778459" cy="487680"/>
-          </a:xfrm>
-          <a:prstGeom prst="rect">
-            <a:avLst/>
-          </a:prstGeom>
-          <a:noFill/>
-        </p:spPr>
-        <p:txBody>
-          <a:bodyPr wrap="square" lIns="0" tIns="0" rIns="0" bIns="0" anchor="t">
-            <a:spAutoFit/>
-          </a:bodyPr>
-          <a:lstStyle/>
-          <a:p>
-            <a:pPr algn="l">
-              <a:lnSpc>
-                <a:spcPct val="110000"/>
-              </a:lnSpc>
-              <a:spcAft>
-                <a:spcPts val="0"/>
-              </a:spcAft>
-            </a:pPr>
-            <a:r>
-              <a:rPr sz="1040" b="0" i="1">
-                <a:solidFill>
-                  <a:srgbClr val="314359"/>
-                </a:solidFill>
-                <a:latin typeface="Arial"/>
-              </a:rPr>
-              <a:t>The +40% is pure earnings and mix — the same multiple on a cleaner, higher-ROIIC core. Any re-rating is upside we underwrite at zero.</a:t>
+              <a:t>≈ 0 reported operating result</a:t>
+            </a:r>
+          </a:p>
+          <a:p>
+            <a:pPr algn="ctr"/>
+            <a:r>
+              <a:rPr sz="830" b="0">
+                <a:solidFill>
+                  <a:srgbClr val="556A83"/>
+                </a:solidFill>
+                <a:latin typeface="Arial"/>
+              </a:rPr>
+              <a:t>so the market prices the whole company as broken</a:t>
             </a:r>
           </a:p>
         </p:txBody>
@@ -23568,468 +23308,6 @@
 </file>
 
 <file path=ppt/slides/slide21.xml><?xml version="1.0" encoding="utf-8"?>
-<p:sld xmlns:a="http://schemas.openxmlformats.org/drawingml/2006/main" xmlns:r="http://schemas.openxmlformats.org/officeDocument/2006/relationships" xmlns:p="http://schemas.openxmlformats.org/presentationml/2006/main">
-  <p:cSld>
-    <p:spTree>
-      <p:nvGrpSpPr>
-        <p:cNvPr id="1" name=""/>
-        <p:cNvGrpSpPr/>
-        <p:nvPr/>
-      </p:nvGrpSpPr>
-      <p:grpSpPr>
-        <a:xfrm>
-          <a:off x="0" y="0"/>
-          <a:ext cx="0" cy="0"/>
-          <a:chOff x="0" y="0"/>
-          <a:chExt cx="0" cy="0"/>
-        </a:xfrm>
-      </p:grpSpPr>
-      <p:sp>
-        <p:nvSpPr>
-          <p:cNvPr id="2" name="Rectangle 1"/>
-          <p:cNvSpPr/>
-          <p:nvPr/>
-        </p:nvSpPr>
-        <p:spPr>
-          <a:xfrm>
-            <a:off x="0" y="0"/>
-            <a:ext cx="9753600" cy="7315200"/>
-          </a:xfrm>
-          <a:prstGeom prst="rect">
-            <a:avLst/>
-          </a:prstGeom>
-          <a:solidFill>
-            <a:srgbClr val="FFFFFF"/>
-          </a:solidFill>
-          <a:ln>
-            <a:noFill/>
-          </a:ln>
-          <a:effectLst/>
-        </p:spPr>
-        <p:style>
-          <a:lnRef idx="1">
-            <a:schemeClr val="accent1"/>
-          </a:lnRef>
-          <a:fillRef idx="3">
-            <a:schemeClr val="accent1"/>
-          </a:fillRef>
-          <a:effectRef idx="2">
-            <a:schemeClr val="accent1"/>
-          </a:effectRef>
-          <a:fontRef idx="minor">
-            <a:schemeClr val="lt1"/>
-          </a:fontRef>
-        </p:style>
-        <p:txBody>
-          <a:bodyPr rtlCol="0" anchor="ctr"/>
-          <a:lstStyle/>
-          <a:p>
-            <a:pPr algn="ctr"/>
-            <a:endParaRPr/>
-          </a:p>
-        </p:txBody>
-      </p:sp>
-      <p:pic>
-        <p:nvPicPr>
-          <p:cNvPr id="3" name="Picture 2" descr="mark_dark.png"/>
-          <p:cNvPicPr>
-            <a:picLocks noChangeAspect="1"/>
-          </p:cNvPicPr>
-          <p:nvPr/>
-        </p:nvPicPr>
-        <p:blipFill>
-          <a:blip r:embed="rId2"/>
-          <a:stretch>
-            <a:fillRect/>
-          </a:stretch>
-        </p:blipFill>
-        <p:spPr>
-          <a:xfrm>
-            <a:off x="402346" y="234086"/>
-            <a:ext cx="224012" cy="190199"/>
-          </a:xfrm>
-          <a:prstGeom prst="rect">
-            <a:avLst/>
-          </a:prstGeom>
-        </p:spPr>
-      </p:pic>
-      <p:sp>
-        <p:nvSpPr>
-          <p:cNvPr id="4" name="TextBox 3"/>
-          <p:cNvSpPr txBox="1"/>
-          <p:nvPr/>
-        </p:nvSpPr>
-        <p:spPr>
-          <a:xfrm>
-            <a:off x="716907" y="263347"/>
-            <a:ext cx="5120768" cy="292608"/>
-          </a:xfrm>
-          <a:prstGeom prst="rect">
-            <a:avLst/>
-          </a:prstGeom>
-          <a:noFill/>
-        </p:spPr>
-        <p:txBody>
-          <a:bodyPr wrap="square" lIns="0" tIns="0" rIns="0" bIns="0" anchor="t">
-            <a:spAutoFit/>
-          </a:bodyPr>
-          <a:lstStyle/>
-          <a:p>
-            <a:pPr algn="l">
-              <a:lnSpc>
-                <a:spcPct val="110000"/>
-              </a:lnSpc>
-              <a:spcAft>
-                <a:spcPts val="0"/>
-              </a:spcAft>
-            </a:pPr>
-            <a:r>
-              <a:rPr sz="880" b="0" i="0">
-                <a:solidFill>
-                  <a:srgbClr val="556A83"/>
-                </a:solidFill>
-                <a:latin typeface="Arial"/>
-              </a:rPr>
-              <a:t>Track Record</a:t>
-            </a:r>
-          </a:p>
-        </p:txBody>
-      </p:sp>
-      <p:sp>
-        <p:nvSpPr>
-          <p:cNvPr id="5" name="TextBox 4"/>
-          <p:cNvSpPr txBox="1"/>
-          <p:nvPr/>
-        </p:nvSpPr>
-        <p:spPr>
-          <a:xfrm>
-            <a:off x="7242229" y="263347"/>
-            <a:ext cx="2084884" cy="292608"/>
-          </a:xfrm>
-          <a:prstGeom prst="rect">
-            <a:avLst/>
-          </a:prstGeom>
-          <a:noFill/>
-        </p:spPr>
-        <p:txBody>
-          <a:bodyPr wrap="square" lIns="0" tIns="0" rIns="0" bIns="0" anchor="t">
-            <a:spAutoFit/>
-          </a:bodyPr>
-          <a:lstStyle/>
-          <a:p>
-            <a:pPr algn="r">
-              <a:lnSpc>
-                <a:spcPct val="110000"/>
-              </a:lnSpc>
-              <a:spcAft>
-                <a:spcPts val="0"/>
-              </a:spcAft>
-            </a:pPr>
-            <a:r>
-              <a:rPr sz="880" b="1" i="0">
-                <a:solidFill>
-                  <a:srgbClr val="556A83"/>
-                </a:solidFill>
-                <a:latin typeface="Arial"/>
-              </a:rPr>
-              <a:t>Figure 5</a:t>
-            </a:r>
-          </a:p>
-        </p:txBody>
-      </p:sp>
-      <p:sp>
-        <p:nvSpPr>
-          <p:cNvPr id="6" name="Rectangle 5"/>
-          <p:cNvSpPr/>
-          <p:nvPr/>
-        </p:nvSpPr>
-        <p:spPr>
-          <a:xfrm>
-            <a:off x="0" y="604723"/>
-            <a:ext cx="9753600" cy="1024128"/>
-          </a:xfrm>
-          <a:prstGeom prst="rect">
-            <a:avLst/>
-          </a:prstGeom>
-          <a:solidFill>
-            <a:srgbClr val="F6F7F9"/>
-          </a:solidFill>
-          <a:ln>
-            <a:noFill/>
-          </a:ln>
-          <a:effectLst/>
-        </p:spPr>
-        <p:style>
-          <a:lnRef idx="1">
-            <a:schemeClr val="accent1"/>
-          </a:lnRef>
-          <a:fillRef idx="3">
-            <a:schemeClr val="accent1"/>
-          </a:fillRef>
-          <a:effectRef idx="2">
-            <a:schemeClr val="accent1"/>
-          </a:effectRef>
-          <a:fontRef idx="minor">
-            <a:schemeClr val="lt1"/>
-          </a:fontRef>
-        </p:style>
-        <p:txBody>
-          <a:bodyPr rtlCol="0" anchor="ctr"/>
-          <a:lstStyle/>
-          <a:p>
-            <a:pPr algn="ctr"/>
-            <a:endParaRPr/>
-          </a:p>
-        </p:txBody>
-      </p:sp>
-      <p:sp>
-        <p:nvSpPr>
-          <p:cNvPr id="7" name="TextBox 6"/>
-          <p:cNvSpPr txBox="1"/>
-          <p:nvPr/>
-        </p:nvSpPr>
-        <p:spPr>
-          <a:xfrm>
-            <a:off x="438922" y="721766"/>
-            <a:ext cx="8851613" cy="829056"/>
-          </a:xfrm>
-          <a:prstGeom prst="rect">
-            <a:avLst/>
-          </a:prstGeom>
-          <a:noFill/>
-        </p:spPr>
-        <p:txBody>
-          <a:bodyPr wrap="square" lIns="0" tIns="0" rIns="0" bIns="0" anchor="t">
-            <a:spAutoFit/>
-          </a:bodyPr>
-          <a:lstStyle/>
-          <a:p>
-            <a:pPr algn="l">
-              <a:lnSpc>
-                <a:spcPct val="110000"/>
-              </a:lnSpc>
-              <a:spcAft>
-                <a:spcPts val="200"/>
-              </a:spcAft>
-            </a:pPr>
-            <a:r>
-              <a:rPr sz="2400" b="0" i="0" spc="-90">
-                <a:solidFill>
-                  <a:srgbClr val="314359"/>
-                </a:solidFill>
-                <a:latin typeface="Times New Roman"/>
-              </a:rPr>
-              <a:t>Proof: outperformance with downside protection</a:t>
-            </a:r>
-          </a:p>
-        </p:txBody>
-      </p:sp>
-      <p:sp>
-        <p:nvSpPr>
-          <p:cNvPr id="8" name="TextBox 7"/>
-          <p:cNvSpPr txBox="1"/>
-          <p:nvPr/>
-        </p:nvSpPr>
-        <p:spPr>
-          <a:xfrm>
-            <a:off x="6583844" y="6876288"/>
-            <a:ext cx="2926153" cy="292608"/>
-          </a:xfrm>
-          <a:prstGeom prst="rect">
-            <a:avLst/>
-          </a:prstGeom>
-          <a:noFill/>
-        </p:spPr>
-        <p:txBody>
-          <a:bodyPr wrap="square" lIns="0" tIns="0" rIns="0" bIns="0" anchor="t">
-            <a:spAutoFit/>
-          </a:bodyPr>
-          <a:lstStyle/>
-          <a:p>
-            <a:pPr algn="r">
-              <a:lnSpc>
-                <a:spcPct val="110000"/>
-              </a:lnSpc>
-              <a:spcAft>
-                <a:spcPts val="0"/>
-              </a:spcAft>
-            </a:pPr>
-            <a:r>
-              <a:rPr sz="680" b="0" i="0">
-                <a:solidFill>
-                  <a:srgbClr val="556A83"/>
-                </a:solidFill>
-                <a:latin typeface="Arial"/>
-              </a:rPr>
-              <a:t>Strictly confidential          21</a:t>
-            </a:r>
-          </a:p>
-        </p:txBody>
-      </p:sp>
-      <p:graphicFrame>
-        <p:nvGraphicFramePr>
-          <p:cNvPr id="9" name="Chart 8"/>
-          <p:cNvGraphicFramePr>
-            <a:graphicFrameLocks noGrp="1"/>
-          </p:cNvGraphicFramePr>
-          <p:nvPr/>
-        </p:nvGraphicFramePr>
-        <p:xfrm>
-          <a:off x="512076" y="1901952"/>
-          <a:ext cx="5193921" cy="4096512"/>
-        </p:xfrm>
-        <a:graphic>
-          <a:graphicData uri="http://schemas.openxmlformats.org/drawingml/2006/chart">
-            <c:chart xmlns:c="http://schemas.openxmlformats.org/drawingml/2006/chart" xmlns:r="http://schemas.openxmlformats.org/officeDocument/2006/relationships" r:id="rId3"/>
-          </a:graphicData>
-        </a:graphic>
-      </p:graphicFrame>
-      <p:sp>
-        <p:nvSpPr>
-          <p:cNvPr id="10" name="TextBox 9"/>
-          <p:cNvSpPr txBox="1"/>
-          <p:nvPr/>
-        </p:nvSpPr>
-        <p:spPr>
-          <a:xfrm>
-            <a:off x="5925460" y="1999488"/>
-            <a:ext cx="3365076" cy="4389120"/>
-          </a:xfrm>
-          <a:prstGeom prst="rect">
-            <a:avLst/>
-          </a:prstGeom>
-          <a:noFill/>
-        </p:spPr>
-        <p:txBody>
-          <a:bodyPr wrap="square" lIns="0" tIns="0" rIns="0" bIns="0" anchor="t">
-            <a:spAutoFit/>
-          </a:bodyPr>
-          <a:lstStyle/>
-          <a:p>
-            <a:pPr algn="l">
-              <a:lnSpc>
-                <a:spcPct val="110000"/>
-              </a:lnSpc>
-              <a:spcAft>
-                <a:spcPts val="200"/>
-              </a:spcAft>
-            </a:pPr>
-            <a:r>
-              <a:rPr sz="1280" b="1" i="0">
-                <a:solidFill>
-                  <a:srgbClr val="314359"/>
-                </a:solidFill>
-                <a:latin typeface="Times New Roman"/>
-              </a:rPr>
-              <a:t>Win by losing less</a:t>
-            </a:r>
-          </a:p>
-          <a:p>
-            <a:pPr algn="l">
-              <a:lnSpc>
-                <a:spcPct val="115000"/>
-              </a:lnSpc>
-              <a:spcAft>
-                <a:spcPts val="1400"/>
-              </a:spcAft>
-            </a:pPr>
-            <a:r>
-              <a:rPr sz="1040" b="0" i="0">
-                <a:solidFill>
-                  <a:srgbClr val="0E1620"/>
-                </a:solidFill>
-                <a:latin typeface="Arial"/>
-              </a:rPr>
-              <a:t>Athanase keeps pace in up markets but takes less than half the downside — 93% up-capture, 43% down-capture. The asymmetry, not outsized rallies, is the edge.</a:t>
-            </a:r>
-          </a:p>
-          <a:p>
-            <a:pPr algn="l">
-              <a:lnSpc>
-                <a:spcPct val="110000"/>
-              </a:lnSpc>
-              <a:spcAft>
-                <a:spcPts val="200"/>
-              </a:spcAft>
-            </a:pPr>
-            <a:r>
-              <a:rPr sz="1280" b="1" i="0">
-                <a:solidFill>
-                  <a:srgbClr val="314359"/>
-                </a:solidFill>
-                <a:latin typeface="Times New Roman"/>
-              </a:rPr>
-              <a:t>And it compounds</a:t>
-            </a:r>
-          </a:p>
-          <a:p>
-            <a:pPr algn="l">
-              <a:lnSpc>
-                <a:spcPct val="115000"/>
-              </a:lnSpc>
-              <a:spcAft>
-                <a:spcPts val="1400"/>
-              </a:spcAft>
-            </a:pPr>
-            <a:r>
-              <a:rPr sz="1040" b="0" i="0">
-                <a:solidFill>
-                  <a:srgbClr val="0E1620"/>
-                </a:solidFill>
-                <a:latin typeface="Arial"/>
-              </a:rPr>
-              <a:t>Losing less in every drawdown leaves more capital working in the recovery. Since 2006 that turned each €1 into ~€18 of capital — 18× growth, versus ~3.2× for the market.</a:t>
-            </a:r>
-          </a:p>
-          <a:p>
-            <a:pPr algn="l">
-              <a:lnSpc>
-                <a:spcPct val="110000"/>
-              </a:lnSpc>
-              <a:spcAft>
-                <a:spcPts val="200"/>
-              </a:spcAft>
-            </a:pPr>
-            <a:r>
-              <a:rPr sz="1280" b="1" i="0">
-                <a:solidFill>
-                  <a:srgbClr val="314359"/>
-                </a:solidFill>
-                <a:latin typeface="Times New Roman"/>
-              </a:rPr>
-              <a:t>Net of every fee</a:t>
-            </a:r>
-          </a:p>
-          <a:p>
-            <a:pPr algn="l">
-              <a:lnSpc>
-                <a:spcPct val="115000"/>
-              </a:lnSpc>
-              <a:spcAft>
-                <a:spcPts val="0"/>
-              </a:spcAft>
-            </a:pPr>
-            <a:r>
-              <a:rPr sz="1040" b="0" i="0">
-                <a:solidFill>
-                  <a:srgbClr val="0E1620"/>
-                </a:solidFill>
-                <a:latin typeface="Arial"/>
-              </a:rPr>
-              <a:t>16.3% net per year versus the market’s 6.2% — about +10 points a year, after all fees and across two full market cycles.</a:t>
-            </a:r>
-          </a:p>
-        </p:txBody>
-      </p:sp>
-    </p:spTree>
-  </p:cSld>
-  <p:clrMapOvr>
-    <a:masterClrMapping/>
-  </p:clrMapOvr>
-</p:sld>
-</file>
-
-<file path=ppt/slides/slide22.xml><?xml version="1.0" encoding="utf-8"?>
 <p:sld xmlns:a="http://schemas.openxmlformats.org/drawingml/2006/main" xmlns:r="http://schemas.openxmlformats.org/officeDocument/2006/relationships" xmlns:p="http://schemas.openxmlformats.org/presentationml/2006/main">
   <p:cSld>
     <p:spTree>

</xml_diff>

<commit_message>
Retitle for the audience: AI-concentration risk, plain language
Family-office audience are business owners, not allocators, and want
diversification away from the AI/Mag-7-concentrated index. New title:
'Don't bet your wealth on a handful of AI stocks' (controlled 2-line break).
Updated core title property to match.

https://claude.ai/code/session_01HRMxSvt6t94q3GFGUqavQe
</commit_message>
<xml_diff>
--- a/Athanase_Endowment_Pitch_21pp.pptx
+++ b/Athanase_Endowment_Pitch_21pp.pptx
@@ -4494,7 +4494,7 @@
                 </a:solidFill>
                 <a:latin typeface="Times New Roman"/>
               </a:rPr>
-              <a:t>Athanase diversifies your portfolio</a:t>
+              <a:t>Don’t bet your wealth</a:t>
             </a:r>
             <a:endParaRPr sz="3360" b="0" i="0" spc="-126" dirty="0">
               <a:solidFill>
@@ -4502,6 +4502,16 @@
               </a:solidFill>
               <a:latin typeface="Times New Roman"/>
             </a:endParaRPr>
+            <a:br/>
+            <a:r>
+              <a:rPr lang="en-GB" sz="3360" spc="-126" dirty="0">
+                <a:solidFill>
+                  <a:srgbClr val="FFFFFF"/>
+                </a:solidFill>
+                <a:latin typeface="Times New Roman"/>
+              </a:rPr>
+              <a:t>on a handful of AI stocks</a:t>
+            </a:r>
           </a:p>
           <a:p>
             <a:pPr algn="l">

</xml_diff>

<commit_message>
Title: 'Your index is now a bet on AI — diversify it'
https://claude.ai/code/session_01HRMxSvt6t94q3GFGUqavQe
</commit_message>
<xml_diff>
--- a/Athanase_Endowment_Pitch_21pp.pptx
+++ b/Athanase_Endowment_Pitch_21pp.pptx
@@ -4494,14 +4494,8 @@
                 </a:solidFill>
                 <a:latin typeface="Times New Roman"/>
               </a:rPr>
-              <a:t>Don’t bet your wealth</a:t>
-            </a:r>
-            <a:endParaRPr sz="3360" b="0" i="0" spc="-126" dirty="0">
-              <a:solidFill>
-                <a:srgbClr val="FFFFFF"/>
-              </a:solidFill>
-              <a:latin typeface="Times New Roman"/>
-            </a:endParaRPr>
+              <a:t>Your index is now a bet on AI</a:t>
+            </a:r>
             <a:br/>
             <a:r>
               <a:rPr lang="en-GB" sz="3360" spc="-126" dirty="0">
@@ -4510,7 +4504,7 @@
                 </a:solidFill>
                 <a:latin typeface="Times New Roman"/>
               </a:rPr>
-              <a:t>on a handful of AI stocks</a:t>
+              <a:t>— diversify it</a:t>
             </a:r>
           </a:p>
           <a:p>

</xml_diff>